<commit_message>
what does this program do
</commit_message>
<xml_diff>
--- a/all/ExploringCSConceptsViaACSLCompetitions_all.pptx
+++ b/all/ExploringCSConceptsViaACSLCompetitions_all.pptx
@@ -5,7 +5,7 @@
     <p:sldMasterId id="2147483648" r:id="rId1"/>
   </p:sldMasterIdLst>
   <p:notesMasterIdLst>
-    <p:notesMasterId r:id="rId89"/>
+    <p:notesMasterId r:id="rId102"/>
   </p:notesMasterIdLst>
   <p:sldIdLst>
     <p:sldId id="256" r:id="rId2"/>
@@ -87,14 +87,27 @@
     <p:sldId id="344" r:id="rId78"/>
     <p:sldId id="345" r:id="rId79"/>
     <p:sldId id="347" r:id="rId80"/>
-    <p:sldId id="349" r:id="rId81"/>
-    <p:sldId id="351" r:id="rId82"/>
-    <p:sldId id="353" r:id="rId83"/>
-    <p:sldId id="352" r:id="rId84"/>
-    <p:sldId id="354" r:id="rId85"/>
-    <p:sldId id="350" r:id="rId86"/>
-    <p:sldId id="355" r:id="rId87"/>
-    <p:sldId id="356" r:id="rId88"/>
+    <p:sldId id="357" r:id="rId81"/>
+    <p:sldId id="349" r:id="rId82"/>
+    <p:sldId id="351" r:id="rId83"/>
+    <p:sldId id="353" r:id="rId84"/>
+    <p:sldId id="352" r:id="rId85"/>
+    <p:sldId id="354" r:id="rId86"/>
+    <p:sldId id="350" r:id="rId87"/>
+    <p:sldId id="355" r:id="rId88"/>
+    <p:sldId id="356" r:id="rId89"/>
+    <p:sldId id="358" r:id="rId90"/>
+    <p:sldId id="367" r:id="rId91"/>
+    <p:sldId id="359" r:id="rId92"/>
+    <p:sldId id="368" r:id="rId93"/>
+    <p:sldId id="360" r:id="rId94"/>
+    <p:sldId id="369" r:id="rId95"/>
+    <p:sldId id="361" r:id="rId96"/>
+    <p:sldId id="370" r:id="rId97"/>
+    <p:sldId id="363" r:id="rId98"/>
+    <p:sldId id="371" r:id="rId99"/>
+    <p:sldId id="366" r:id="rId100"/>
+    <p:sldId id="372" r:id="rId101"/>
   </p:sldIdLst>
   <p:sldSz cx="12192000" cy="6858000"/>
   <p:notesSz cx="6858000" cy="9144000"/>
@@ -472,7 +485,7 @@
           <a:p>
             <a:fld id="{15653688-98A8-4F3B-A740-8E6568AE1BCB}" type="datetimeFigureOut">
               <a:rPr lang="en-US" smtClean="0"/>
-              <a:t>3/5/2026</a:t>
+              <a:t>3/19/2026</a:t>
             </a:fld>
             <a:endParaRPr lang="en-US"/>
           </a:p>
@@ -2226,7 +2239,7 @@
           <a:p>
             <a:fld id="{20CB266D-A331-4A79-AB46-FEF40B16CF9B}" type="datetimeFigureOut">
               <a:rPr lang="en-US" smtClean="0"/>
-              <a:t>3/5/2026</a:t>
+              <a:t>3/19/2026</a:t>
             </a:fld>
             <a:endParaRPr lang="en-US"/>
           </a:p>
@@ -2424,7 +2437,7 @@
           <a:p>
             <a:fld id="{20CB266D-A331-4A79-AB46-FEF40B16CF9B}" type="datetimeFigureOut">
               <a:rPr lang="en-US" smtClean="0"/>
-              <a:t>3/5/2026</a:t>
+              <a:t>3/19/2026</a:t>
             </a:fld>
             <a:endParaRPr lang="en-US"/>
           </a:p>
@@ -2632,7 +2645,7 @@
           <a:p>
             <a:fld id="{20CB266D-A331-4A79-AB46-FEF40B16CF9B}" type="datetimeFigureOut">
               <a:rPr lang="en-US" smtClean="0"/>
-              <a:t>3/5/2026</a:t>
+              <a:t>3/19/2026</a:t>
             </a:fld>
             <a:endParaRPr lang="en-US"/>
           </a:p>
@@ -2830,7 +2843,7 @@
           <a:p>
             <a:fld id="{20CB266D-A331-4A79-AB46-FEF40B16CF9B}" type="datetimeFigureOut">
               <a:rPr lang="en-US" smtClean="0"/>
-              <a:t>3/5/2026</a:t>
+              <a:t>3/19/2026</a:t>
             </a:fld>
             <a:endParaRPr lang="en-US"/>
           </a:p>
@@ -3105,7 +3118,7 @@
           <a:p>
             <a:fld id="{20CB266D-A331-4A79-AB46-FEF40B16CF9B}" type="datetimeFigureOut">
               <a:rPr lang="en-US" smtClean="0"/>
-              <a:t>3/5/2026</a:t>
+              <a:t>3/19/2026</a:t>
             </a:fld>
             <a:endParaRPr lang="en-US"/>
           </a:p>
@@ -3370,7 +3383,7 @@
           <a:p>
             <a:fld id="{20CB266D-A331-4A79-AB46-FEF40B16CF9B}" type="datetimeFigureOut">
               <a:rPr lang="en-US" smtClean="0"/>
-              <a:t>3/5/2026</a:t>
+              <a:t>3/19/2026</a:t>
             </a:fld>
             <a:endParaRPr lang="en-US"/>
           </a:p>
@@ -3782,7 +3795,7 @@
           <a:p>
             <a:fld id="{20CB266D-A331-4A79-AB46-FEF40B16CF9B}" type="datetimeFigureOut">
               <a:rPr lang="en-US" smtClean="0"/>
-              <a:t>3/5/2026</a:t>
+              <a:t>3/19/2026</a:t>
             </a:fld>
             <a:endParaRPr lang="en-US"/>
           </a:p>
@@ -3923,7 +3936,7 @@
           <a:p>
             <a:fld id="{20CB266D-A331-4A79-AB46-FEF40B16CF9B}" type="datetimeFigureOut">
               <a:rPr lang="en-US" smtClean="0"/>
-              <a:t>3/5/2026</a:t>
+              <a:t>3/19/2026</a:t>
             </a:fld>
             <a:endParaRPr lang="en-US"/>
           </a:p>
@@ -4036,7 +4049,7 @@
           <a:p>
             <a:fld id="{20CB266D-A331-4A79-AB46-FEF40B16CF9B}" type="datetimeFigureOut">
               <a:rPr lang="en-US" smtClean="0"/>
-              <a:t>3/5/2026</a:t>
+              <a:t>3/19/2026</a:t>
             </a:fld>
             <a:endParaRPr lang="en-US"/>
           </a:p>
@@ -4347,7 +4360,7 @@
           <a:p>
             <a:fld id="{20CB266D-A331-4A79-AB46-FEF40B16CF9B}" type="datetimeFigureOut">
               <a:rPr lang="en-US" smtClean="0"/>
-              <a:t>3/5/2026</a:t>
+              <a:t>3/19/2026</a:t>
             </a:fld>
             <a:endParaRPr lang="en-US"/>
           </a:p>
@@ -4635,7 +4648,7 @@
           <a:p>
             <a:fld id="{20CB266D-A331-4A79-AB46-FEF40B16CF9B}" type="datetimeFigureOut">
               <a:rPr lang="en-US" smtClean="0"/>
-              <a:t>3/5/2026</a:t>
+              <a:t>3/19/2026</a:t>
             </a:fld>
             <a:endParaRPr lang="en-US"/>
           </a:p>
@@ -4876,7 +4889,7 @@
           <a:p>
             <a:fld id="{20CB266D-A331-4A79-AB46-FEF40B16CF9B}" type="datetimeFigureOut">
               <a:rPr lang="en-US" smtClean="0"/>
-              <a:t>3/5/2026</a:t>
+              <a:t>3/19/2026</a:t>
             </a:fld>
             <a:endParaRPr lang="en-US"/>
           </a:p>
@@ -5558,6 +5571,181 @@
     <p:extLst>
       <p:ext uri="{BB962C8B-B14F-4D97-AF65-F5344CB8AC3E}">
         <p14:creationId xmlns:p14="http://schemas.microsoft.com/office/powerpoint/2010/main" val="3428240167"/>
+      </p:ext>
+    </p:extLst>
+  </p:cSld>
+  <p:clrMapOvr>
+    <a:masterClrMapping/>
+  </p:clrMapOvr>
+</p:sld>
+</file>
+
+<file path=ppt/slides/slide100.xml><?xml version="1.0" encoding="utf-8"?>
+<p:sld xmlns:a="http://schemas.openxmlformats.org/drawingml/2006/main" xmlns:r="http://schemas.openxmlformats.org/officeDocument/2006/relationships" xmlns:p="http://schemas.openxmlformats.org/presentationml/2006/main">
+  <p:cSld>
+    <p:spTree>
+      <p:nvGrpSpPr>
+        <p:cNvPr id="1" name="">
+          <a:extLst>
+            <a:ext uri="{FF2B5EF4-FFF2-40B4-BE49-F238E27FC236}">
+              <a16:creationId xmlns:a16="http://schemas.microsoft.com/office/drawing/2014/main" id="{271978AA-FE52-CD93-522C-CD1CAD6EA1FF}"/>
+            </a:ext>
+          </a:extLst>
+        </p:cNvPr>
+        <p:cNvGrpSpPr/>
+        <p:nvPr/>
+      </p:nvGrpSpPr>
+      <p:grpSpPr>
+        <a:xfrm>
+          <a:off x="0" y="0"/>
+          <a:ext cx="0" cy="0"/>
+          <a:chOff x="0" y="0"/>
+          <a:chExt cx="0" cy="0"/>
+        </a:xfrm>
+      </p:grpSpPr>
+      <p:sp>
+        <p:nvSpPr>
+          <p:cNvPr id="2" name="Title 1">
+            <a:extLst>
+              <a:ext uri="{FF2B5EF4-FFF2-40B4-BE49-F238E27FC236}">
+                <a16:creationId xmlns:a16="http://schemas.microsoft.com/office/drawing/2014/main" id="{182D0B23-C7DE-7BD3-3432-914ED568A952}"/>
+              </a:ext>
+            </a:extLst>
+          </p:cNvPr>
+          <p:cNvSpPr>
+            <a:spLocks noGrp="1"/>
+          </p:cNvSpPr>
+          <p:nvPr>
+            <p:ph type="title"/>
+          </p:nvPr>
+        </p:nvSpPr>
+        <p:spPr/>
+        <p:txBody>
+          <a:bodyPr/>
+          <a:lstStyle/>
+          <a:p>
+            <a:r>
+              <a:rPr lang="en-US" dirty="0"/>
+              <a:t>What does this program do ? </a:t>
+            </a:r>
+            <a:r>
+              <a:rPr lang="en-US"/>
+              <a:t>A6</a:t>
+            </a:r>
+            <a:endParaRPr lang="en-US" dirty="0"/>
+          </a:p>
+        </p:txBody>
+      </p:sp>
+      <p:sp>
+        <p:nvSpPr>
+          <p:cNvPr id="4" name="Content Placeholder 3">
+            <a:extLst>
+              <a:ext uri="{FF2B5EF4-FFF2-40B4-BE49-F238E27FC236}">
+                <a16:creationId xmlns:a16="http://schemas.microsoft.com/office/drawing/2014/main" id="{F311FF15-17C3-E624-760A-CCA518D19322}"/>
+              </a:ext>
+            </a:extLst>
+          </p:cNvPr>
+          <p:cNvSpPr>
+            <a:spLocks noGrp="1"/>
+          </p:cNvSpPr>
+          <p:nvPr>
+            <p:ph idx="1"/>
+          </p:nvPr>
+        </p:nvSpPr>
+        <p:spPr/>
+        <p:txBody>
+          <a:bodyPr/>
+          <a:lstStyle/>
+          <a:p>
+            <a:r>
+              <a:rPr lang="en-US" dirty="0"/>
+              <a:t>1 2 3 4</a:t>
+            </a:r>
+          </a:p>
+          <a:p>
+            <a:pPr lvl="1"/>
+            <a:r>
+              <a:rPr lang="en-US" dirty="0"/>
+              <a:t>Bubble sort</a:t>
+            </a:r>
+          </a:p>
+          <a:p>
+            <a:pPr lvl="2"/>
+            <a:r>
+              <a:rPr lang="en-US" dirty="0"/>
+              <a:t>Pass 1 </a:t>
+            </a:r>
+            <a:r>
+              <a:rPr lang="en-US" dirty="0">
+                <a:sym typeface="Wingdings" panose="05000000000000000000" pitchFamily="2" charset="2"/>
+              </a:rPr>
+              <a:t> 1,3,2,4</a:t>
+            </a:r>
+          </a:p>
+          <a:p>
+            <a:pPr lvl="2"/>
+            <a:r>
+              <a:rPr lang="en-US" dirty="0">
+                <a:sym typeface="Wingdings" panose="05000000000000000000" pitchFamily="2" charset="2"/>
+              </a:rPr>
+              <a:t>Pass 2  1,2,3,4</a:t>
+            </a:r>
+          </a:p>
+          <a:p>
+            <a:pPr lvl="2"/>
+            <a:r>
+              <a:rPr lang="en-US" dirty="0">
+                <a:sym typeface="Wingdings" panose="05000000000000000000" pitchFamily="2" charset="2"/>
+              </a:rPr>
+              <a:t>Pass 3  (No Change)</a:t>
+            </a:r>
+          </a:p>
+          <a:p>
+            <a:pPr lvl="2"/>
+            <a:r>
+              <a:rPr lang="en-US" dirty="0">
+                <a:sym typeface="Wingdings" panose="05000000000000000000" pitchFamily="2" charset="2"/>
+              </a:rPr>
+              <a:t>Pass 4  (No Change)</a:t>
+            </a:r>
+            <a:endParaRPr lang="en-US" dirty="0"/>
+          </a:p>
+        </p:txBody>
+      </p:sp>
+      <p:pic>
+        <p:nvPicPr>
+          <p:cNvPr id="6" name="Content Placeholder 4">
+            <a:extLst>
+              <a:ext uri="{FF2B5EF4-FFF2-40B4-BE49-F238E27FC236}">
+                <a16:creationId xmlns:a16="http://schemas.microsoft.com/office/drawing/2014/main" id="{481A62B2-389D-56BD-B428-9D0DBD6C135E}"/>
+              </a:ext>
+            </a:extLst>
+          </p:cNvPr>
+          <p:cNvPicPr>
+            <a:picLocks noChangeAspect="1"/>
+          </p:cNvPicPr>
+          <p:nvPr/>
+        </p:nvPicPr>
+        <p:blipFill>
+          <a:blip r:embed="rId2"/>
+          <a:stretch>
+            <a:fillRect/>
+          </a:stretch>
+        </p:blipFill>
+        <p:spPr>
+          <a:xfrm>
+            <a:off x="5683469" y="1943866"/>
+            <a:ext cx="4660660" cy="3876704"/>
+          </a:xfrm>
+          <a:prstGeom prst="rect">
+            <a:avLst/>
+          </a:prstGeom>
+        </p:spPr>
+      </p:pic>
+    </p:spTree>
+    <p:extLst>
+      <p:ext uri="{BB962C8B-B14F-4D97-AF65-F5344CB8AC3E}">
+        <p14:creationId xmlns:p14="http://schemas.microsoft.com/office/powerpoint/2010/main" val="2440834063"/>
       </p:ext>
     </p:extLst>
   </p:cSld>
@@ -32589,17 +32777,10 @@
             </p:nvSpPr>
             <p:spPr/>
             <p:txBody>
-              <a:bodyPr/>
+              <a:bodyPr>
+                <a:normAutofit lnSpcReduction="10000"/>
+              </a:bodyPr>
               <a:lstStyle/>
-              <a:p>
-                <a:r>
-                  <a:rPr lang="en-US" dirty="0"/>
-                  <a:t>These are hard , think of them as puzzles,</a:t>
-                </a:r>
-                <a:endParaRPr lang="en-US" i="1" dirty="0">
-                  <a:latin typeface="Cambria Math" panose="02040503050406030204" pitchFamily="18" charset="0"/>
-                </a:endParaRPr>
-              </a:p>
               <a:p>
                 <a:pPr lvl="1"/>
                 <a14:m>
@@ -32734,6 +32915,40 @@
                 </a:endParaRPr>
               </a:p>
               <a:p>
+                <a:pPr lvl="2"/>
+                <a14:m>
+                  <m:oMath xmlns:m="http://schemas.openxmlformats.org/officeDocument/2006/math">
+                    <m:r>
+                      <a:rPr lang="en-US" b="1" i="1" smtClean="0">
+                        <a:latin typeface="Cambria Math" panose="02040503050406030204" pitchFamily="18" charset="0"/>
+                      </a:rPr>
+                      <m:t> </m:t>
+                    </m:r>
+                    <m:r>
+                      <a:rPr lang="en-US" b="1" i="1" smtClean="0">
+                        <a:latin typeface="Cambria Math" panose="02040503050406030204" pitchFamily="18" charset="0"/>
+                      </a:rPr>
+                      <m:t>𝑨</m:t>
+                    </m:r>
+                    <m:r>
+                      <a:rPr lang="en-US" b="1" i="1" smtClean="0">
+                        <a:latin typeface="Cambria Math" panose="02040503050406030204" pitchFamily="18" charset="0"/>
+                      </a:rPr>
+                      <m:t>+</m:t>
+                    </m:r>
+                    <m:r>
+                      <a:rPr lang="en-US" b="1" i="1" smtClean="0">
+                        <a:latin typeface="Cambria Math" panose="02040503050406030204" pitchFamily="18" charset="0"/>
+                      </a:rPr>
+                      <m:t>𝑪</m:t>
+                    </m:r>
+                  </m:oMath>
+                </a14:m>
+                <a:endParaRPr lang="en-US" b="1" i="1" dirty="0">
+                  <a:latin typeface="Cambria Math" panose="02040503050406030204" pitchFamily="18" charset="0"/>
+                </a:endParaRPr>
+              </a:p>
+              <a:p>
                 <a:pPr lvl="1"/>
                 <a14:m>
                   <m:oMath xmlns:m="http://schemas.openxmlformats.org/officeDocument/2006/math">
@@ -32860,9 +33075,43 @@
                         </m:r>
                       </m:e>
                     </m:d>
+                    <m:r>
+                      <a:rPr lang="en-US" b="0" i="1" smtClean="0">
+                        <a:latin typeface="Cambria Math" panose="02040503050406030204" pitchFamily="18" charset="0"/>
+                      </a:rPr>
+                      <m:t> </m:t>
+                    </m:r>
                   </m:oMath>
                 </a14:m>
                 <a:endParaRPr lang="en-US" i="1" dirty="0">
+                  <a:latin typeface="Cambria Math" panose="02040503050406030204" pitchFamily="18" charset="0"/>
+                </a:endParaRPr>
+              </a:p>
+              <a:p>
+                <a:pPr lvl="2"/>
+                <a14:m>
+                  <m:oMath xmlns:m="http://schemas.openxmlformats.org/officeDocument/2006/math">
+                    <m:r>
+                      <a:rPr lang="en-US" b="1" i="1" smtClean="0">
+                        <a:latin typeface="Cambria Math" panose="02040503050406030204" pitchFamily="18" charset="0"/>
+                      </a:rPr>
+                      <m:t>𝑨</m:t>
+                    </m:r>
+                    <m:r>
+                      <a:rPr lang="en-US" b="1" i="1" smtClean="0">
+                        <a:latin typeface="Cambria Math" panose="02040503050406030204" pitchFamily="18" charset="0"/>
+                      </a:rPr>
+                      <m:t>.</m:t>
+                    </m:r>
+                    <m:r>
+                      <a:rPr lang="en-US" b="1" i="1" smtClean="0">
+                        <a:latin typeface="Cambria Math" panose="02040503050406030204" pitchFamily="18" charset="0"/>
+                      </a:rPr>
+                      <m:t>𝑩</m:t>
+                    </m:r>
+                  </m:oMath>
+                </a14:m>
+                <a:endParaRPr lang="en-US" b="1" i="1" dirty="0">
                   <a:latin typeface="Cambria Math" panose="02040503050406030204" pitchFamily="18" charset="0"/>
                 </a:endParaRPr>
               </a:p>
@@ -32943,6 +33192,34 @@
                 </a:endParaRPr>
               </a:p>
               <a:p>
+                <a:pPr lvl="2"/>
+                <a14:m>
+                  <m:oMath xmlns:m="http://schemas.openxmlformats.org/officeDocument/2006/math">
+                    <m:acc>
+                      <m:accPr>
+                        <m:chr m:val="̅"/>
+                        <m:ctrlPr>
+                          <a:rPr lang="en-US" b="1" i="1">
+                            <a:latin typeface="Cambria Math" panose="02040503050406030204" pitchFamily="18" charset="0"/>
+                          </a:rPr>
+                        </m:ctrlPr>
+                      </m:accPr>
+                      <m:e>
+                        <m:r>
+                          <a:rPr lang="en-US" b="1" i="1">
+                            <a:latin typeface="Cambria Math" panose="02040503050406030204" pitchFamily="18" charset="0"/>
+                          </a:rPr>
+                          <m:t>𝑩</m:t>
+                        </m:r>
+                      </m:e>
+                    </m:acc>
+                  </m:oMath>
+                </a14:m>
+                <a:endParaRPr lang="en-US" b="1" i="1" dirty="0">
+                  <a:latin typeface="Cambria Math" panose="02040503050406030204" pitchFamily="18" charset="0"/>
+                </a:endParaRPr>
+              </a:p>
+              <a:p>
                 <a:pPr lvl="1"/>
                 <a14:m>
                   <m:oMath xmlns:m="http://schemas.openxmlformats.org/officeDocument/2006/math">
@@ -33074,6 +33351,61 @@
                 </a14:m>
                 <a:r>
                   <a:rPr lang="en-US" i="1" dirty="0">
+                    <a:latin typeface="Cambria Math" panose="02040503050406030204" pitchFamily="18" charset="0"/>
+                  </a:rPr>
+                  <a:t>)</a:t>
+                </a:r>
+              </a:p>
+              <a:p>
+                <a:pPr lvl="2"/>
+                <a14:m>
+                  <m:oMath xmlns:m="http://schemas.openxmlformats.org/officeDocument/2006/math">
+                    <m:r>
+                      <a:rPr lang="en-US" b="1" i="1" smtClean="0">
+                        <a:latin typeface="Cambria Math" panose="02040503050406030204" pitchFamily="18" charset="0"/>
+                      </a:rPr>
+                      <m:t>𝑩</m:t>
+                    </m:r>
+                    <m:r>
+                      <a:rPr lang="en-US" b="1" i="1" smtClean="0">
+                        <a:latin typeface="Cambria Math" panose="02040503050406030204" pitchFamily="18" charset="0"/>
+                      </a:rPr>
+                      <m:t>.(</m:t>
+                    </m:r>
+                    <m:r>
+                      <a:rPr lang="en-US" b="1" i="1" smtClean="0">
+                        <a:latin typeface="Cambria Math" panose="02040503050406030204" pitchFamily="18" charset="0"/>
+                      </a:rPr>
+                      <m:t>𝑨</m:t>
+                    </m:r>
+                    <m:r>
+                      <a:rPr lang="en-US" b="1" i="1" smtClean="0">
+                        <a:latin typeface="Cambria Math" panose="02040503050406030204" pitchFamily="18" charset="0"/>
+                      </a:rPr>
+                      <m:t>+</m:t>
+                    </m:r>
+                    <m:acc>
+                      <m:accPr>
+                        <m:chr m:val="̅"/>
+                        <m:ctrlPr>
+                          <a:rPr lang="en-US" b="1" i="1" smtClean="0">
+                            <a:latin typeface="Cambria Math" panose="02040503050406030204" pitchFamily="18" charset="0"/>
+                          </a:rPr>
+                        </m:ctrlPr>
+                      </m:accPr>
+                      <m:e>
+                        <m:r>
+                          <a:rPr lang="en-US" b="1" i="1" smtClean="0">
+                            <a:latin typeface="Cambria Math" panose="02040503050406030204" pitchFamily="18" charset="0"/>
+                          </a:rPr>
+                          <m:t>𝑪</m:t>
+                        </m:r>
+                      </m:e>
+                    </m:acc>
+                  </m:oMath>
+                </a14:m>
+                <a:r>
+                  <a:rPr lang="en-US" b="1" i="1" dirty="0">
                     <a:latin typeface="Cambria Math" panose="02040503050406030204" pitchFamily="18" charset="0"/>
                   </a:rPr>
                   <a:t>)</a:t>
@@ -33214,6 +33546,100 @@
                 </a:endParaRPr>
               </a:p>
               <a:p>
+                <a:pPr lvl="2"/>
+                <a14:m>
+                  <m:oMath xmlns:m="http://schemas.openxmlformats.org/officeDocument/2006/math">
+                    <m:r>
+                      <a:rPr lang="en-US" b="1" i="1" smtClean="0">
+                        <a:latin typeface="Cambria Math" panose="02040503050406030204" pitchFamily="18" charset="0"/>
+                      </a:rPr>
+                      <m:t>𝑨</m:t>
+                    </m:r>
+                    <m:r>
+                      <a:rPr lang="en-US" b="1" i="1" smtClean="0">
+                        <a:latin typeface="Cambria Math" panose="02040503050406030204" pitchFamily="18" charset="0"/>
+                      </a:rPr>
+                      <m:t>.</m:t>
+                    </m:r>
+                    <m:acc>
+                      <m:accPr>
+                        <m:chr m:val="̅"/>
+                        <m:ctrlPr>
+                          <a:rPr lang="en-US" b="1" i="1">
+                            <a:latin typeface="Cambria Math" panose="02040503050406030204" pitchFamily="18" charset="0"/>
+                          </a:rPr>
+                        </m:ctrlPr>
+                      </m:accPr>
+                      <m:e>
+                        <m:r>
+                          <a:rPr lang="en-US" b="1" i="1">
+                            <a:latin typeface="Cambria Math" panose="02040503050406030204" pitchFamily="18" charset="0"/>
+                          </a:rPr>
+                          <m:t>𝑩</m:t>
+                        </m:r>
+                        <m:r>
+                          <a:rPr lang="en-US" b="1" i="1" smtClean="0">
+                            <a:latin typeface="Cambria Math" panose="02040503050406030204" pitchFamily="18" charset="0"/>
+                          </a:rPr>
+                          <m:t>𝑪</m:t>
+                        </m:r>
+                      </m:e>
+                    </m:acc>
+                    <m:r>
+                      <a:rPr lang="en-US" b="1" i="1" smtClean="0">
+                        <a:latin typeface="Cambria Math" panose="02040503050406030204" pitchFamily="18" charset="0"/>
+                      </a:rPr>
+                      <m:t>+ </m:t>
+                    </m:r>
+                    <m:acc>
+                      <m:accPr>
+                        <m:chr m:val="̅"/>
+                        <m:ctrlPr>
+                          <a:rPr lang="en-US" b="1" i="1">
+                            <a:latin typeface="Cambria Math" panose="02040503050406030204" pitchFamily="18" charset="0"/>
+                          </a:rPr>
+                        </m:ctrlPr>
+                      </m:accPr>
+                      <m:e>
+                        <m:r>
+                          <a:rPr lang="en-US" b="1" i="1">
+                            <a:latin typeface="Cambria Math" panose="02040503050406030204" pitchFamily="18" charset="0"/>
+                          </a:rPr>
+                          <m:t>𝑨</m:t>
+                        </m:r>
+                      </m:e>
+                    </m:acc>
+                    <m:r>
+                      <a:rPr lang="en-US" b="1" i="1">
+                        <a:latin typeface="Cambria Math" panose="02040503050406030204" pitchFamily="18" charset="0"/>
+                      </a:rPr>
+                      <m:t>.</m:t>
+                    </m:r>
+                    <m:r>
+                      <a:rPr lang="en-US" b="1" i="1" smtClean="0">
+                        <a:latin typeface="Cambria Math" panose="02040503050406030204" pitchFamily="18" charset="0"/>
+                      </a:rPr>
+                      <m:t>𝑩</m:t>
+                    </m:r>
+                    <m:r>
+                      <a:rPr lang="en-US" b="1" i="1" smtClean="0">
+                        <a:latin typeface="Cambria Math" panose="02040503050406030204" pitchFamily="18" charset="0"/>
+                      </a:rPr>
+                      <m:t>.</m:t>
+                    </m:r>
+                    <m:r>
+                      <a:rPr lang="en-US" b="1" i="1">
+                        <a:latin typeface="Cambria Math" panose="02040503050406030204" pitchFamily="18" charset="0"/>
+                      </a:rPr>
+                      <m:t>𝑪</m:t>
+                    </m:r>
+                  </m:oMath>
+                </a14:m>
+                <a:endParaRPr lang="en-US" b="1" i="1" dirty="0">
+                  <a:latin typeface="Cambria Math" panose="02040503050406030204" pitchFamily="18" charset="0"/>
+                </a:endParaRPr>
+              </a:p>
+              <a:p>
                 <a:pPr lvl="1"/>
                 <a14:m>
                   <m:oMath xmlns:m="http://schemas.openxmlformats.org/officeDocument/2006/math">
@@ -33361,6 +33787,92 @@
                   <a:t>)</a:t>
                 </a:r>
               </a:p>
+              <a:p>
+                <a:pPr lvl="2"/>
+                <a14:m>
+                  <m:oMath xmlns:m="http://schemas.openxmlformats.org/officeDocument/2006/math">
+                    <m:acc>
+                      <m:accPr>
+                        <m:chr m:val="̅"/>
+                        <m:ctrlPr>
+                          <a:rPr lang="en-US" b="1" i="1" smtClean="0">
+                            <a:latin typeface="Cambria Math" panose="02040503050406030204" pitchFamily="18" charset="0"/>
+                          </a:rPr>
+                        </m:ctrlPr>
+                      </m:accPr>
+                      <m:e>
+                        <m:r>
+                          <a:rPr lang="en-US" b="1" i="1">
+                            <a:latin typeface="Cambria Math" panose="02040503050406030204" pitchFamily="18" charset="0"/>
+                          </a:rPr>
+                          <m:t>𝑨</m:t>
+                        </m:r>
+                      </m:e>
+                    </m:acc>
+                  </m:oMath>
+                </a14:m>
+                <a:r>
+                  <a:rPr lang="en-US" b="1" i="1" dirty="0">
+                    <a:latin typeface="Cambria Math" panose="02040503050406030204" pitchFamily="18" charset="0"/>
+                  </a:rPr>
+                  <a:t> + </a:t>
+                </a:r>
+                <a14:m>
+                  <m:oMath xmlns:m="http://schemas.openxmlformats.org/officeDocument/2006/math">
+                    <m:acc>
+                      <m:accPr>
+                        <m:chr m:val="̅"/>
+                        <m:ctrlPr>
+                          <a:rPr lang="en-US" b="1" i="1">
+                            <a:latin typeface="Cambria Math" panose="02040503050406030204" pitchFamily="18" charset="0"/>
+                          </a:rPr>
+                        </m:ctrlPr>
+                      </m:accPr>
+                      <m:e>
+                        <m:r>
+                          <a:rPr lang="en-US" b="1" i="1" smtClean="0">
+                            <a:latin typeface="Cambria Math" panose="02040503050406030204" pitchFamily="18" charset="0"/>
+                          </a:rPr>
+                          <m:t>𝑩</m:t>
+                        </m:r>
+                      </m:e>
+                    </m:acc>
+                    <m:r>
+                      <a:rPr lang="en-US" b="1" i="1" smtClean="0">
+                        <a:latin typeface="Cambria Math" panose="02040503050406030204" pitchFamily="18" charset="0"/>
+                      </a:rPr>
+                      <m:t>+</m:t>
+                    </m:r>
+                    <m:acc>
+                      <m:accPr>
+                        <m:chr m:val="̅"/>
+                        <m:ctrlPr>
+                          <a:rPr lang="en-US" b="1" i="1">
+                            <a:latin typeface="Cambria Math" panose="02040503050406030204" pitchFamily="18" charset="0"/>
+                          </a:rPr>
+                        </m:ctrlPr>
+                      </m:accPr>
+                      <m:e>
+                        <m:r>
+                          <a:rPr lang="en-US" b="1" i="1" smtClean="0">
+                            <a:latin typeface="Cambria Math" panose="02040503050406030204" pitchFamily="18" charset="0"/>
+                          </a:rPr>
+                          <m:t>𝑪</m:t>
+                        </m:r>
+                      </m:e>
+                    </m:acc>
+                  </m:oMath>
+                </a14:m>
+                <a:endParaRPr lang="en-US" b="1" i="1" dirty="0">
+                  <a:latin typeface="Cambria Math" panose="02040503050406030204" pitchFamily="18" charset="0"/>
+                </a:endParaRPr>
+              </a:p>
+              <a:p>
+                <a:pPr lvl="2"/>
+                <a:endParaRPr lang="en-US" i="1" dirty="0">
+                  <a:latin typeface="Cambria Math" panose="02040503050406030204" pitchFamily="18" charset="0"/>
+                </a:endParaRPr>
+              </a:p>
             </p:txBody>
           </p:sp>
         </mc:Choice>
@@ -33385,7 +33897,7 @@
               <a:blipFill>
                 <a:blip r:embed="rId2"/>
                 <a:stretch>
-                  <a:fillRect l="-1043" t="-2381"/>
+                  <a:fillRect t="-1261" b="-980"/>
                 </a:stretch>
               </a:blipFill>
             </p:spPr>
@@ -33650,6 +34162,911 @@
   <p:cSld>
     <p:spTree>
       <p:nvGrpSpPr>
+        <p:cNvPr id="1" name="">
+          <a:extLst>
+            <a:ext uri="{FF2B5EF4-FFF2-40B4-BE49-F238E27FC236}">
+              <a16:creationId xmlns:a16="http://schemas.microsoft.com/office/drawing/2014/main" id="{63E9C9B2-45AB-787B-5C91-05A5B558BC8B}"/>
+            </a:ext>
+          </a:extLst>
+        </p:cNvPr>
+        <p:cNvGrpSpPr/>
+        <p:nvPr/>
+      </p:nvGrpSpPr>
+      <p:grpSpPr>
+        <a:xfrm>
+          <a:off x="0" y="0"/>
+          <a:ext cx="0" cy="0"/>
+          <a:chOff x="0" y="0"/>
+          <a:chExt cx="0" cy="0"/>
+        </a:xfrm>
+      </p:grpSpPr>
+      <p:sp>
+        <p:nvSpPr>
+          <p:cNvPr id="2" name="Title 1">
+            <a:extLst>
+              <a:ext uri="{FF2B5EF4-FFF2-40B4-BE49-F238E27FC236}">
+                <a16:creationId xmlns:a16="http://schemas.microsoft.com/office/drawing/2014/main" id="{D13ADC5A-141E-6F8B-7CFB-CAA9C873BD1F}"/>
+              </a:ext>
+            </a:extLst>
+          </p:cNvPr>
+          <p:cNvSpPr>
+            <a:spLocks noGrp="1"/>
+          </p:cNvSpPr>
+          <p:nvPr>
+            <p:ph type="title"/>
+          </p:nvPr>
+        </p:nvSpPr>
+        <p:spPr/>
+        <p:txBody>
+          <a:bodyPr/>
+          <a:lstStyle/>
+          <a:p>
+            <a:r>
+              <a:rPr lang="en-US" dirty="0"/>
+              <a:t>Lets Simplify 5..11 : answers</a:t>
+            </a:r>
+          </a:p>
+        </p:txBody>
+      </p:sp>
+      <mc:AlternateContent xmlns:mc="http://schemas.openxmlformats.org/markup-compatibility/2006" xmlns:a14="http://schemas.microsoft.com/office/drawing/2010/main">
+        <mc:Choice Requires="a14">
+          <p:sp>
+            <p:nvSpPr>
+              <p:cNvPr id="3" name="Content Placeholder 2">
+                <a:extLst>
+                  <a:ext uri="{FF2B5EF4-FFF2-40B4-BE49-F238E27FC236}">
+                    <a16:creationId xmlns:a16="http://schemas.microsoft.com/office/drawing/2014/main" id="{010A3309-A527-5D31-6F50-29E46FDBB2A5}"/>
+                  </a:ext>
+                </a:extLst>
+              </p:cNvPr>
+              <p:cNvSpPr>
+                <a:spLocks noGrp="1"/>
+              </p:cNvSpPr>
+              <p:nvPr>
+                <p:ph idx="1"/>
+              </p:nvPr>
+            </p:nvSpPr>
+            <p:spPr/>
+            <p:txBody>
+              <a:bodyPr/>
+              <a:lstStyle/>
+              <a:p>
+                <a:r>
+                  <a:rPr lang="en-US" dirty="0"/>
+                  <a:t>These are hard , think of them as puzzles,</a:t>
+                </a:r>
+                <a:endParaRPr lang="en-US" i="1" dirty="0">
+                  <a:latin typeface="Cambria Math" panose="02040503050406030204" pitchFamily="18" charset="0"/>
+                </a:endParaRPr>
+              </a:p>
+              <a:p>
+                <a:pPr lvl="1"/>
+                <a14:m>
+                  <m:oMath xmlns:m="http://schemas.openxmlformats.org/officeDocument/2006/math">
+                    <m:d>
+                      <m:dPr>
+                        <m:ctrlPr>
+                          <a:rPr lang="en-US" i="1" smtClean="0">
+                            <a:latin typeface="Cambria Math" panose="02040503050406030204" pitchFamily="18" charset="0"/>
+                          </a:rPr>
+                        </m:ctrlPr>
+                      </m:dPr>
+                      <m:e>
+                        <m:r>
+                          <a:rPr lang="en-US" i="1">
+                            <a:latin typeface="Cambria Math" panose="02040503050406030204" pitchFamily="18" charset="0"/>
+                          </a:rPr>
+                          <m:t>𝐴</m:t>
+                        </m:r>
+                        <m:r>
+                          <a:rPr lang="en-US" i="1">
+                            <a:latin typeface="Cambria Math" panose="02040503050406030204" pitchFamily="18" charset="0"/>
+                          </a:rPr>
+                          <m:t>.</m:t>
+                        </m:r>
+                        <m:r>
+                          <a:rPr lang="en-US" i="1">
+                            <a:latin typeface="Cambria Math" panose="02040503050406030204" pitchFamily="18" charset="0"/>
+                          </a:rPr>
+                          <m:t>𝐵</m:t>
+                        </m:r>
+                      </m:e>
+                    </m:d>
+                    <m:r>
+                      <a:rPr lang="en-US" i="1">
+                        <a:latin typeface="Cambria Math" panose="02040503050406030204" pitchFamily="18" charset="0"/>
+                      </a:rPr>
+                      <m:t>+</m:t>
+                    </m:r>
+                    <m:d>
+                      <m:dPr>
+                        <m:ctrlPr>
+                          <a:rPr lang="en-US" b="0" i="1" smtClean="0">
+                            <a:latin typeface="Cambria Math" panose="02040503050406030204" pitchFamily="18" charset="0"/>
+                          </a:rPr>
+                        </m:ctrlPr>
+                      </m:dPr>
+                      <m:e>
+                        <m:r>
+                          <a:rPr lang="en-US" i="1">
+                            <a:latin typeface="Cambria Math" panose="02040503050406030204" pitchFamily="18" charset="0"/>
+                          </a:rPr>
+                          <m:t>𝐴</m:t>
+                        </m:r>
+                        <m:r>
+                          <a:rPr lang="en-US" i="1">
+                            <a:latin typeface="Cambria Math" panose="02040503050406030204" pitchFamily="18" charset="0"/>
+                          </a:rPr>
+                          <m:t>.</m:t>
+                        </m:r>
+                        <m:acc>
+                          <m:accPr>
+                            <m:chr m:val="̅"/>
+                            <m:ctrlPr>
+                              <a:rPr lang="en-US" i="1">
+                                <a:latin typeface="Cambria Math" panose="02040503050406030204" pitchFamily="18" charset="0"/>
+                              </a:rPr>
+                            </m:ctrlPr>
+                          </m:accPr>
+                          <m:e>
+                            <m:r>
+                              <a:rPr lang="en-US" i="1">
+                                <a:latin typeface="Cambria Math" panose="02040503050406030204" pitchFamily="18" charset="0"/>
+                              </a:rPr>
+                              <m:t>𝐵</m:t>
+                            </m:r>
+                          </m:e>
+                        </m:acc>
+                      </m:e>
+                    </m:d>
+                    <m:r>
+                      <a:rPr lang="en-US" i="1">
+                        <a:latin typeface="Cambria Math" panose="02040503050406030204" pitchFamily="18" charset="0"/>
+                      </a:rPr>
+                      <m:t>+</m:t>
+                    </m:r>
+                    <m:d>
+                      <m:dPr>
+                        <m:ctrlPr>
+                          <a:rPr lang="en-US" i="1">
+                            <a:latin typeface="Cambria Math" panose="02040503050406030204" pitchFamily="18" charset="0"/>
+                          </a:rPr>
+                        </m:ctrlPr>
+                      </m:dPr>
+                      <m:e>
+                        <m:acc>
+                          <m:accPr>
+                            <m:chr m:val="̅"/>
+                            <m:ctrlPr>
+                              <a:rPr lang="en-US" i="1">
+                                <a:latin typeface="Cambria Math" panose="02040503050406030204" pitchFamily="18" charset="0"/>
+                              </a:rPr>
+                            </m:ctrlPr>
+                          </m:accPr>
+                          <m:e>
+                            <m:r>
+                              <a:rPr lang="en-US" i="1">
+                                <a:latin typeface="Cambria Math" panose="02040503050406030204" pitchFamily="18" charset="0"/>
+                              </a:rPr>
+                              <m:t>𝐴</m:t>
+                            </m:r>
+                          </m:e>
+                        </m:acc>
+                        <m:r>
+                          <a:rPr lang="en-US" i="1">
+                            <a:latin typeface="Cambria Math" panose="02040503050406030204" pitchFamily="18" charset="0"/>
+                          </a:rPr>
+                          <m:t>.</m:t>
+                        </m:r>
+                        <m:r>
+                          <a:rPr lang="en-US" i="1">
+                            <a:latin typeface="Cambria Math" panose="02040503050406030204" pitchFamily="18" charset="0"/>
+                          </a:rPr>
+                          <m:t>𝐶</m:t>
+                        </m:r>
+                      </m:e>
+                    </m:d>
+                  </m:oMath>
+                </a14:m>
+                <a:endParaRPr lang="en-US" i="1" dirty="0">
+                  <a:latin typeface="Cambria Math" panose="02040503050406030204" pitchFamily="18" charset="0"/>
+                </a:endParaRPr>
+              </a:p>
+              <a:p>
+                <a:pPr lvl="2"/>
+                <a:endParaRPr lang="en-US" i="1" dirty="0">
+                  <a:latin typeface="Cambria Math" panose="02040503050406030204" pitchFamily="18" charset="0"/>
+                </a:endParaRPr>
+              </a:p>
+              <a:p>
+                <a:pPr lvl="1"/>
+                <a14:m>
+                  <m:oMath xmlns:m="http://schemas.openxmlformats.org/officeDocument/2006/math">
+                    <m:d>
+                      <m:dPr>
+                        <m:ctrlPr>
+                          <a:rPr lang="en-US" i="1" smtClean="0">
+                            <a:latin typeface="Cambria Math" panose="02040503050406030204" pitchFamily="18" charset="0"/>
+                          </a:rPr>
+                        </m:ctrlPr>
+                      </m:dPr>
+                      <m:e>
+                        <m:r>
+                          <a:rPr lang="en-US" i="1">
+                            <a:latin typeface="Cambria Math" panose="02040503050406030204" pitchFamily="18" charset="0"/>
+                          </a:rPr>
+                          <m:t>𝐴</m:t>
+                        </m:r>
+                        <m:r>
+                          <a:rPr lang="en-US" b="0" i="1" smtClean="0">
+                            <a:latin typeface="Cambria Math" panose="02040503050406030204" pitchFamily="18" charset="0"/>
+                          </a:rPr>
+                          <m:t>+</m:t>
+                        </m:r>
+                        <m:r>
+                          <a:rPr lang="en-US" i="1">
+                            <a:latin typeface="Cambria Math" panose="02040503050406030204" pitchFamily="18" charset="0"/>
+                          </a:rPr>
+                          <m:t>𝐵</m:t>
+                        </m:r>
+                      </m:e>
+                    </m:d>
+                    <m:r>
+                      <a:rPr lang="en-US" b="0" i="1" smtClean="0">
+                        <a:latin typeface="Cambria Math" panose="02040503050406030204" pitchFamily="18" charset="0"/>
+                      </a:rPr>
+                      <m:t>.</m:t>
+                    </m:r>
+                    <m:d>
+                      <m:dPr>
+                        <m:ctrlPr>
+                          <a:rPr lang="en-US" b="0" i="1" smtClean="0">
+                            <a:latin typeface="Cambria Math" panose="02040503050406030204" pitchFamily="18" charset="0"/>
+                          </a:rPr>
+                        </m:ctrlPr>
+                      </m:dPr>
+                      <m:e>
+                        <m:r>
+                          <a:rPr lang="en-US" i="1">
+                            <a:latin typeface="Cambria Math" panose="02040503050406030204" pitchFamily="18" charset="0"/>
+                          </a:rPr>
+                          <m:t>𝐴</m:t>
+                        </m:r>
+                        <m:r>
+                          <a:rPr lang="en-US" b="0" i="1" smtClean="0">
+                            <a:latin typeface="Cambria Math" panose="02040503050406030204" pitchFamily="18" charset="0"/>
+                          </a:rPr>
+                          <m:t>+</m:t>
+                        </m:r>
+                        <m:acc>
+                          <m:accPr>
+                            <m:chr m:val="̅"/>
+                            <m:ctrlPr>
+                              <a:rPr lang="en-US" i="1">
+                                <a:latin typeface="Cambria Math" panose="02040503050406030204" pitchFamily="18" charset="0"/>
+                              </a:rPr>
+                            </m:ctrlPr>
+                          </m:accPr>
+                          <m:e>
+                            <m:r>
+                              <a:rPr lang="en-US" i="1">
+                                <a:latin typeface="Cambria Math" panose="02040503050406030204" pitchFamily="18" charset="0"/>
+                              </a:rPr>
+                              <m:t>𝐵</m:t>
+                            </m:r>
+                          </m:e>
+                        </m:acc>
+                      </m:e>
+                    </m:d>
+                    <m:r>
+                      <a:rPr lang="en-US" b="0" i="1" smtClean="0">
+                        <a:latin typeface="Cambria Math" panose="02040503050406030204" pitchFamily="18" charset="0"/>
+                      </a:rPr>
+                      <m:t>.</m:t>
+                    </m:r>
+                    <m:d>
+                      <m:dPr>
+                        <m:ctrlPr>
+                          <a:rPr lang="en-US" i="1">
+                            <a:latin typeface="Cambria Math" panose="02040503050406030204" pitchFamily="18" charset="0"/>
+                          </a:rPr>
+                        </m:ctrlPr>
+                      </m:dPr>
+                      <m:e>
+                        <m:acc>
+                          <m:accPr>
+                            <m:chr m:val="̅"/>
+                            <m:ctrlPr>
+                              <a:rPr lang="en-US" i="1">
+                                <a:latin typeface="Cambria Math" panose="02040503050406030204" pitchFamily="18" charset="0"/>
+                              </a:rPr>
+                            </m:ctrlPr>
+                          </m:accPr>
+                          <m:e>
+                            <m:r>
+                              <a:rPr lang="en-US" i="1">
+                                <a:latin typeface="Cambria Math" panose="02040503050406030204" pitchFamily="18" charset="0"/>
+                              </a:rPr>
+                              <m:t>𝐴</m:t>
+                            </m:r>
+                          </m:e>
+                        </m:acc>
+                        <m:r>
+                          <a:rPr lang="en-US" b="0" i="1" smtClean="0">
+                            <a:latin typeface="Cambria Math" panose="02040503050406030204" pitchFamily="18" charset="0"/>
+                          </a:rPr>
+                          <m:t>+</m:t>
+                        </m:r>
+                        <m:r>
+                          <a:rPr lang="en-US" b="0" i="1" smtClean="0">
+                            <a:latin typeface="Cambria Math" panose="02040503050406030204" pitchFamily="18" charset="0"/>
+                          </a:rPr>
+                          <m:t>𝐵</m:t>
+                        </m:r>
+                      </m:e>
+                    </m:d>
+                  </m:oMath>
+                </a14:m>
+                <a:endParaRPr lang="en-US" i="1" dirty="0">
+                  <a:latin typeface="Cambria Math" panose="02040503050406030204" pitchFamily="18" charset="0"/>
+                </a:endParaRPr>
+              </a:p>
+              <a:p>
+                <a:pPr lvl="1"/>
+                <a14:m>
+                  <m:oMath xmlns:m="http://schemas.openxmlformats.org/officeDocument/2006/math">
+                    <m:acc>
+                      <m:accPr>
+                        <m:chr m:val="̅"/>
+                        <m:ctrlPr>
+                          <a:rPr lang="en-US" i="1" smtClean="0">
+                            <a:latin typeface="Cambria Math" panose="02040503050406030204" pitchFamily="18" charset="0"/>
+                          </a:rPr>
+                        </m:ctrlPr>
+                      </m:accPr>
+                      <m:e>
+                        <m:r>
+                          <a:rPr lang="en-US" b="0" i="1" smtClean="0">
+                            <a:latin typeface="Cambria Math" panose="02040503050406030204" pitchFamily="18" charset="0"/>
+                          </a:rPr>
+                          <m:t>𝐴</m:t>
+                        </m:r>
+                        <m:r>
+                          <a:rPr lang="en-US" b="0" i="1" smtClean="0">
+                            <a:latin typeface="Cambria Math" panose="02040503050406030204" pitchFamily="18" charset="0"/>
+                          </a:rPr>
+                          <m:t>+</m:t>
+                        </m:r>
+                        <m:r>
+                          <a:rPr lang="en-US" b="0" i="1" smtClean="0">
+                            <a:latin typeface="Cambria Math" panose="02040503050406030204" pitchFamily="18" charset="0"/>
+                          </a:rPr>
+                          <m:t>𝐵</m:t>
+                        </m:r>
+                      </m:e>
+                    </m:acc>
+                    <m:r>
+                      <a:rPr lang="en-US" b="0" i="1" smtClean="0">
+                        <a:latin typeface="Cambria Math" panose="02040503050406030204" pitchFamily="18" charset="0"/>
+                      </a:rPr>
+                      <m:t>+</m:t>
+                    </m:r>
+                    <m:r>
+                      <a:rPr lang="en-US" b="0" i="1" smtClean="0">
+                        <a:latin typeface="Cambria Math" panose="02040503050406030204" pitchFamily="18" charset="0"/>
+                      </a:rPr>
+                      <m:t>𝐴</m:t>
+                    </m:r>
+                    <m:r>
+                      <a:rPr lang="en-US" b="0" i="1" smtClean="0">
+                        <a:latin typeface="Cambria Math" panose="02040503050406030204" pitchFamily="18" charset="0"/>
+                      </a:rPr>
+                      <m:t>. </m:t>
+                    </m:r>
+                    <m:acc>
+                      <m:accPr>
+                        <m:chr m:val="̅"/>
+                        <m:ctrlPr>
+                          <a:rPr lang="en-US" i="1">
+                            <a:latin typeface="Cambria Math" panose="02040503050406030204" pitchFamily="18" charset="0"/>
+                          </a:rPr>
+                        </m:ctrlPr>
+                      </m:accPr>
+                      <m:e>
+                        <m:r>
+                          <a:rPr lang="en-US" i="1">
+                            <a:latin typeface="Cambria Math" panose="02040503050406030204" pitchFamily="18" charset="0"/>
+                          </a:rPr>
+                          <m:t>𝐵</m:t>
+                        </m:r>
+                      </m:e>
+                    </m:acc>
+                  </m:oMath>
+                </a14:m>
+                <a:endParaRPr lang="en-US" i="1" dirty="0">
+                  <a:latin typeface="Cambria Math" panose="02040503050406030204" pitchFamily="18" charset="0"/>
+                </a:endParaRPr>
+              </a:p>
+              <a:p>
+                <a:pPr lvl="1"/>
+                <a14:m>
+                  <m:oMath xmlns:m="http://schemas.openxmlformats.org/officeDocument/2006/math">
+                    <m:d>
+                      <m:dPr>
+                        <m:ctrlPr>
+                          <a:rPr lang="en-US" i="1" smtClean="0">
+                            <a:latin typeface="Cambria Math" panose="02040503050406030204" pitchFamily="18" charset="0"/>
+                          </a:rPr>
+                        </m:ctrlPr>
+                      </m:dPr>
+                      <m:e>
+                        <m:r>
+                          <a:rPr lang="en-US" i="1">
+                            <a:latin typeface="Cambria Math" panose="02040503050406030204" pitchFamily="18" charset="0"/>
+                          </a:rPr>
+                          <m:t>𝐴</m:t>
+                        </m:r>
+                        <m:r>
+                          <a:rPr lang="en-US" b="0" i="1" smtClean="0">
+                            <a:latin typeface="Cambria Math" panose="02040503050406030204" pitchFamily="18" charset="0"/>
+                          </a:rPr>
+                          <m:t>+</m:t>
+                        </m:r>
+                        <m:r>
+                          <a:rPr lang="en-US" i="1">
+                            <a:latin typeface="Cambria Math" panose="02040503050406030204" pitchFamily="18" charset="0"/>
+                          </a:rPr>
+                          <m:t>𝐵</m:t>
+                        </m:r>
+                        <m:r>
+                          <a:rPr lang="en-US" b="0" i="1" smtClean="0">
+                            <a:latin typeface="Cambria Math" panose="02040503050406030204" pitchFamily="18" charset="0"/>
+                          </a:rPr>
+                          <m:t>+</m:t>
+                        </m:r>
+                        <m:r>
+                          <a:rPr lang="en-US" b="0" i="1" smtClean="0">
+                            <a:latin typeface="Cambria Math" panose="02040503050406030204" pitchFamily="18" charset="0"/>
+                          </a:rPr>
+                          <m:t>𝐶</m:t>
+                        </m:r>
+                      </m:e>
+                    </m:d>
+                    <m:r>
+                      <a:rPr lang="en-US" b="0" i="1" smtClean="0">
+                        <a:latin typeface="Cambria Math" panose="02040503050406030204" pitchFamily="18" charset="0"/>
+                      </a:rPr>
+                      <m:t>.</m:t>
+                    </m:r>
+                    <m:d>
+                      <m:dPr>
+                        <m:ctrlPr>
+                          <a:rPr lang="en-US" i="1">
+                            <a:latin typeface="Cambria Math" panose="02040503050406030204" pitchFamily="18" charset="0"/>
+                          </a:rPr>
+                        </m:ctrlPr>
+                      </m:dPr>
+                      <m:e>
+                        <m:acc>
+                          <m:accPr>
+                            <m:chr m:val="̅"/>
+                            <m:ctrlPr>
+                              <a:rPr lang="en-US" i="1">
+                                <a:latin typeface="Cambria Math" panose="02040503050406030204" pitchFamily="18" charset="0"/>
+                              </a:rPr>
+                            </m:ctrlPr>
+                          </m:accPr>
+                          <m:e>
+                            <m:r>
+                              <a:rPr lang="en-US" i="1">
+                                <a:latin typeface="Cambria Math" panose="02040503050406030204" pitchFamily="18" charset="0"/>
+                              </a:rPr>
+                              <m:t>𝐴</m:t>
+                            </m:r>
+                          </m:e>
+                        </m:acc>
+                        <m:r>
+                          <a:rPr lang="en-US" b="0" i="1" smtClean="0">
+                            <a:latin typeface="Cambria Math" panose="02040503050406030204" pitchFamily="18" charset="0"/>
+                          </a:rPr>
+                          <m:t>+</m:t>
+                        </m:r>
+                        <m:r>
+                          <a:rPr lang="en-US" b="0" i="1" smtClean="0">
+                            <a:latin typeface="Cambria Math" panose="02040503050406030204" pitchFamily="18" charset="0"/>
+                          </a:rPr>
+                          <m:t>𝐵</m:t>
+                        </m:r>
+                      </m:e>
+                    </m:d>
+                    <m:r>
+                      <a:rPr lang="en-US" b="0" i="1" smtClean="0">
+                        <a:latin typeface="Cambria Math" panose="02040503050406030204" pitchFamily="18" charset="0"/>
+                      </a:rPr>
+                      <m:t>.(</m:t>
+                    </m:r>
+                    <m:r>
+                      <a:rPr lang="en-US" b="0" i="1" smtClean="0">
+                        <a:latin typeface="Cambria Math" panose="02040503050406030204" pitchFamily="18" charset="0"/>
+                      </a:rPr>
+                      <m:t>𝐴</m:t>
+                    </m:r>
+                    <m:r>
+                      <a:rPr lang="en-US" b="0" i="1" smtClean="0">
+                        <a:latin typeface="Cambria Math" panose="02040503050406030204" pitchFamily="18" charset="0"/>
+                      </a:rPr>
+                      <m:t>+</m:t>
+                    </m:r>
+                    <m:acc>
+                      <m:accPr>
+                        <m:chr m:val="̅"/>
+                        <m:ctrlPr>
+                          <a:rPr lang="en-US" b="0" i="1" smtClean="0">
+                            <a:latin typeface="Cambria Math" panose="02040503050406030204" pitchFamily="18" charset="0"/>
+                          </a:rPr>
+                        </m:ctrlPr>
+                      </m:accPr>
+                      <m:e>
+                        <m:r>
+                          <a:rPr lang="en-US" b="0" i="1" smtClean="0">
+                            <a:latin typeface="Cambria Math" panose="02040503050406030204" pitchFamily="18" charset="0"/>
+                          </a:rPr>
+                          <m:t>𝐶</m:t>
+                        </m:r>
+                      </m:e>
+                    </m:acc>
+                  </m:oMath>
+                </a14:m>
+                <a:r>
+                  <a:rPr lang="en-US" i="1" dirty="0">
+                    <a:latin typeface="Cambria Math" panose="02040503050406030204" pitchFamily="18" charset="0"/>
+                  </a:rPr>
+                  <a:t>)</a:t>
+                </a:r>
+              </a:p>
+              <a:p>
+                <a:pPr lvl="1"/>
+                <a14:m>
+                  <m:oMath xmlns:m="http://schemas.openxmlformats.org/officeDocument/2006/math">
+                    <m:d>
+                      <m:dPr>
+                        <m:ctrlPr>
+                          <a:rPr lang="en-US" b="0" i="1" smtClean="0">
+                            <a:latin typeface="Cambria Math" panose="02040503050406030204" pitchFamily="18" charset="0"/>
+                          </a:rPr>
+                        </m:ctrlPr>
+                      </m:dPr>
+                      <m:e>
+                        <m:r>
+                          <a:rPr lang="en-US" i="1">
+                            <a:latin typeface="Cambria Math" panose="02040503050406030204" pitchFamily="18" charset="0"/>
+                          </a:rPr>
+                          <m:t>𝐴</m:t>
+                        </m:r>
+                        <m:r>
+                          <a:rPr lang="en-US" b="0" i="1" smtClean="0">
+                            <a:latin typeface="Cambria Math" panose="02040503050406030204" pitchFamily="18" charset="0"/>
+                          </a:rPr>
+                          <m:t>.</m:t>
+                        </m:r>
+                        <m:acc>
+                          <m:accPr>
+                            <m:chr m:val="̅"/>
+                            <m:ctrlPr>
+                              <a:rPr lang="en-US" i="1">
+                                <a:latin typeface="Cambria Math" panose="02040503050406030204" pitchFamily="18" charset="0"/>
+                              </a:rPr>
+                            </m:ctrlPr>
+                          </m:accPr>
+                          <m:e>
+                            <m:r>
+                              <a:rPr lang="en-US" i="1">
+                                <a:latin typeface="Cambria Math" panose="02040503050406030204" pitchFamily="18" charset="0"/>
+                              </a:rPr>
+                              <m:t>𝐵</m:t>
+                            </m:r>
+                          </m:e>
+                        </m:acc>
+                        <m:r>
+                          <a:rPr lang="en-US" b="0" i="1" smtClean="0">
+                            <a:latin typeface="Cambria Math" panose="02040503050406030204" pitchFamily="18" charset="0"/>
+                          </a:rPr>
+                          <m:t>+</m:t>
+                        </m:r>
+                        <m:r>
+                          <a:rPr lang="en-US" b="0" i="1" smtClean="0">
+                            <a:latin typeface="Cambria Math" panose="02040503050406030204" pitchFamily="18" charset="0"/>
+                          </a:rPr>
+                          <m:t>𝐵</m:t>
+                        </m:r>
+                        <m:r>
+                          <a:rPr lang="en-US" b="0" i="1" smtClean="0">
+                            <a:latin typeface="Cambria Math" panose="02040503050406030204" pitchFamily="18" charset="0"/>
+                          </a:rPr>
+                          <m:t>.</m:t>
+                        </m:r>
+                        <m:r>
+                          <a:rPr lang="en-US" b="0" i="1" smtClean="0">
+                            <a:latin typeface="Cambria Math" panose="02040503050406030204" pitchFamily="18" charset="0"/>
+                          </a:rPr>
+                          <m:t>𝐶</m:t>
+                        </m:r>
+                      </m:e>
+                    </m:d>
+                    <m:r>
+                      <a:rPr lang="en-US" b="0" i="1" smtClean="0">
+                        <a:latin typeface="Cambria Math" panose="02040503050406030204" pitchFamily="18" charset="0"/>
+                      </a:rPr>
+                      <m:t>.</m:t>
+                    </m:r>
+                    <m:d>
+                      <m:dPr>
+                        <m:ctrlPr>
+                          <a:rPr lang="en-US" b="0" i="1" smtClean="0">
+                            <a:latin typeface="Cambria Math" panose="02040503050406030204" pitchFamily="18" charset="0"/>
+                          </a:rPr>
+                        </m:ctrlPr>
+                      </m:dPr>
+                      <m:e>
+                        <m:acc>
+                          <m:accPr>
+                            <m:chr m:val="̅"/>
+                            <m:ctrlPr>
+                              <a:rPr lang="en-US" i="1">
+                                <a:latin typeface="Cambria Math" panose="02040503050406030204" pitchFamily="18" charset="0"/>
+                              </a:rPr>
+                            </m:ctrlPr>
+                          </m:accPr>
+                          <m:e>
+                            <m:r>
+                              <a:rPr lang="en-US" i="1">
+                                <a:latin typeface="Cambria Math" panose="02040503050406030204" pitchFamily="18" charset="0"/>
+                              </a:rPr>
+                              <m:t>𝐴</m:t>
+                            </m:r>
+                          </m:e>
+                        </m:acc>
+                        <m:r>
+                          <a:rPr lang="en-US" b="0" i="1" smtClean="0">
+                            <a:latin typeface="Cambria Math" panose="02040503050406030204" pitchFamily="18" charset="0"/>
+                          </a:rPr>
+                          <m:t>+</m:t>
+                        </m:r>
+                        <m:acc>
+                          <m:accPr>
+                            <m:chr m:val="̅"/>
+                            <m:ctrlPr>
+                              <a:rPr lang="en-US" i="1">
+                                <a:latin typeface="Cambria Math" panose="02040503050406030204" pitchFamily="18" charset="0"/>
+                              </a:rPr>
+                            </m:ctrlPr>
+                          </m:accPr>
+                          <m:e>
+                            <m:r>
+                              <a:rPr lang="en-US" i="1">
+                                <a:latin typeface="Cambria Math" panose="02040503050406030204" pitchFamily="18" charset="0"/>
+                              </a:rPr>
+                              <m:t>𝐶</m:t>
+                            </m:r>
+                          </m:e>
+                        </m:acc>
+                      </m:e>
+                    </m:d>
+                  </m:oMath>
+                </a14:m>
+                <a:endParaRPr lang="en-US" b="0" i="1" dirty="0">
+                  <a:latin typeface="Cambria Math" panose="02040503050406030204" pitchFamily="18" charset="0"/>
+                </a:endParaRPr>
+              </a:p>
+              <a:p>
+                <a:pPr lvl="1"/>
+                <a14:m>
+                  <m:oMath xmlns:m="http://schemas.openxmlformats.org/officeDocument/2006/math">
+                    <m:acc>
+                      <m:accPr>
+                        <m:chr m:val="̅"/>
+                        <m:ctrlPr>
+                          <a:rPr lang="en-US" i="1" smtClean="0">
+                            <a:latin typeface="Cambria Math" panose="02040503050406030204" pitchFamily="18" charset="0"/>
+                          </a:rPr>
+                        </m:ctrlPr>
+                      </m:accPr>
+                      <m:e>
+                        <m:r>
+                          <a:rPr lang="en-US" b="0" i="1" smtClean="0">
+                            <a:latin typeface="Cambria Math" panose="02040503050406030204" pitchFamily="18" charset="0"/>
+                          </a:rPr>
+                          <m:t>(</m:t>
+                        </m:r>
+                        <m:r>
+                          <a:rPr lang="en-US" b="0" i="1" smtClean="0">
+                            <a:latin typeface="Cambria Math" panose="02040503050406030204" pitchFamily="18" charset="0"/>
+                          </a:rPr>
+                          <m:t>𝐴</m:t>
+                        </m:r>
+                        <m:r>
+                          <a:rPr lang="en-US" b="0" i="1" smtClean="0">
+                            <a:latin typeface="Cambria Math" panose="02040503050406030204" pitchFamily="18" charset="0"/>
+                          </a:rPr>
+                          <m:t>.</m:t>
+                        </m:r>
+                        <m:r>
+                          <a:rPr lang="en-US" b="0" i="1" smtClean="0">
+                            <a:latin typeface="Cambria Math" panose="02040503050406030204" pitchFamily="18" charset="0"/>
+                          </a:rPr>
+                          <m:t>𝐵</m:t>
+                        </m:r>
+                        <m:r>
+                          <a:rPr lang="en-US" b="0" i="1" smtClean="0">
+                            <a:latin typeface="Cambria Math" panose="02040503050406030204" pitchFamily="18" charset="0"/>
+                          </a:rPr>
+                          <m:t>)</m:t>
+                        </m:r>
+                      </m:e>
+                    </m:acc>
+                    <m:r>
+                      <a:rPr lang="en-US" b="0" i="1" smtClean="0">
+                        <a:latin typeface="Cambria Math" panose="02040503050406030204" pitchFamily="18" charset="0"/>
+                      </a:rPr>
+                      <m:t> </m:t>
+                    </m:r>
+                  </m:oMath>
+                </a14:m>
+                <a:r>
+                  <a:rPr lang="en-US" i="1" dirty="0">
+                    <a:latin typeface="Cambria Math" panose="02040503050406030204" pitchFamily="18" charset="0"/>
+                  </a:rPr>
+                  <a:t>.</a:t>
+                </a:r>
+                <a14:m>
+                  <m:oMath xmlns:m="http://schemas.openxmlformats.org/officeDocument/2006/math">
+                    <m:d>
+                      <m:dPr>
+                        <m:ctrlPr>
+                          <a:rPr lang="en-US" i="1">
+                            <a:latin typeface="Cambria Math" panose="02040503050406030204" pitchFamily="18" charset="0"/>
+                          </a:rPr>
+                        </m:ctrlPr>
+                      </m:dPr>
+                      <m:e>
+                        <m:acc>
+                          <m:accPr>
+                            <m:chr m:val="̅"/>
+                            <m:ctrlPr>
+                              <a:rPr lang="en-US" i="1">
+                                <a:latin typeface="Cambria Math" panose="02040503050406030204" pitchFamily="18" charset="0"/>
+                              </a:rPr>
+                            </m:ctrlPr>
+                          </m:accPr>
+                          <m:e>
+                            <m:r>
+                              <a:rPr lang="en-US" i="1">
+                                <a:latin typeface="Cambria Math" panose="02040503050406030204" pitchFamily="18" charset="0"/>
+                              </a:rPr>
+                              <m:t>𝐴</m:t>
+                            </m:r>
+                          </m:e>
+                        </m:acc>
+                        <m:r>
+                          <a:rPr lang="en-US" i="1">
+                            <a:latin typeface="Cambria Math" panose="02040503050406030204" pitchFamily="18" charset="0"/>
+                          </a:rPr>
+                          <m:t>+</m:t>
+                        </m:r>
+                        <m:r>
+                          <a:rPr lang="en-US" b="0" i="1" smtClean="0">
+                            <a:latin typeface="Cambria Math" panose="02040503050406030204" pitchFamily="18" charset="0"/>
+                          </a:rPr>
+                          <m:t>𝐶</m:t>
+                        </m:r>
+                      </m:e>
+                    </m:d>
+                    <m:r>
+                      <a:rPr lang="en-US" b="0" i="1" smtClean="0">
+                        <a:latin typeface="Cambria Math" panose="02040503050406030204" pitchFamily="18" charset="0"/>
+                      </a:rPr>
+                      <m:t>+(</m:t>
+                    </m:r>
+                    <m:r>
+                      <a:rPr lang="en-US" b="0" i="1" smtClean="0">
+                        <a:latin typeface="Cambria Math" panose="02040503050406030204" pitchFamily="18" charset="0"/>
+                      </a:rPr>
+                      <m:t>𝐴</m:t>
+                    </m:r>
+                    <m:r>
+                      <a:rPr lang="en-US" b="0" i="1" smtClean="0">
+                        <a:latin typeface="Cambria Math" panose="02040503050406030204" pitchFamily="18" charset="0"/>
+                      </a:rPr>
+                      <m:t>.</m:t>
+                    </m:r>
+                    <m:acc>
+                      <m:accPr>
+                        <m:chr m:val="̅"/>
+                        <m:ctrlPr>
+                          <a:rPr lang="en-US" i="1">
+                            <a:latin typeface="Cambria Math" panose="02040503050406030204" pitchFamily="18" charset="0"/>
+                          </a:rPr>
+                        </m:ctrlPr>
+                      </m:accPr>
+                      <m:e>
+                        <m:r>
+                          <a:rPr lang="en-US" i="1">
+                            <a:latin typeface="Cambria Math" panose="02040503050406030204" pitchFamily="18" charset="0"/>
+                          </a:rPr>
+                          <m:t>𝐶</m:t>
+                        </m:r>
+                      </m:e>
+                    </m:acc>
+                  </m:oMath>
+                </a14:m>
+                <a:r>
+                  <a:rPr lang="en-US" i="1" dirty="0">
+                    <a:latin typeface="Cambria Math" panose="02040503050406030204" pitchFamily="18" charset="0"/>
+                  </a:rPr>
+                  <a:t>)</a:t>
+                </a:r>
+              </a:p>
+            </p:txBody>
+          </p:sp>
+        </mc:Choice>
+        <mc:Fallback xmlns="">
+          <p:sp>
+            <p:nvSpPr>
+              <p:cNvPr id="3" name="Content Placeholder 2">
+                <a:extLst>
+                  <a:ext uri="{FF2B5EF4-FFF2-40B4-BE49-F238E27FC236}">
+                    <a16:creationId xmlns:a16="http://schemas.microsoft.com/office/drawing/2014/main" id="{010A3309-A527-5D31-6F50-29E46FDBB2A5}"/>
+                  </a:ext>
+                </a:extLst>
+              </p:cNvPr>
+              <p:cNvSpPr>
+                <a:spLocks noGrp="1" noRot="1" noChangeAspect="1" noMove="1" noResize="1" noEditPoints="1" noAdjustHandles="1" noChangeArrowheads="1" noChangeShapeType="1" noTextEdit="1"/>
+              </p:cNvSpPr>
+              <p:nvPr>
+                <p:ph idx="1"/>
+              </p:nvPr>
+            </p:nvSpPr>
+            <p:spPr>
+              <a:blipFill>
+                <a:blip r:embed="rId2"/>
+                <a:stretch>
+                  <a:fillRect l="-1043" t="-2381"/>
+                </a:stretch>
+              </a:blipFill>
+            </p:spPr>
+            <p:txBody>
+              <a:bodyPr/>
+              <a:lstStyle/>
+              <a:p>
+                <a:r>
+                  <a:rPr lang="en-US">
+                    <a:noFill/>
+                  </a:rPr>
+                  <a:t> </a:t>
+                </a:r>
+              </a:p>
+            </p:txBody>
+          </p:sp>
+        </mc:Fallback>
+      </mc:AlternateContent>
+    </p:spTree>
+    <p:extLst>
+      <p:ext uri="{BB962C8B-B14F-4D97-AF65-F5344CB8AC3E}">
+        <p14:creationId xmlns:p14="http://schemas.microsoft.com/office/powerpoint/2010/main" val="998742316"/>
+      </p:ext>
+    </p:extLst>
+  </p:cSld>
+  <p:clrMapOvr>
+    <a:masterClrMapping/>
+  </p:clrMapOvr>
+</p:sld>
+</file>
+
+<file path=ppt/slides/slide81.xml><?xml version="1.0" encoding="utf-8"?>
+<p:sld xmlns:a="http://schemas.openxmlformats.org/drawingml/2006/main" xmlns:r="http://schemas.openxmlformats.org/officeDocument/2006/relationships" xmlns:p="http://schemas.openxmlformats.org/presentationml/2006/main">
+  <p:cSld>
+    <p:spTree>
+      <p:nvGrpSpPr>
         <p:cNvPr id="1" name=""/>
         <p:cNvGrpSpPr/>
         <p:nvPr/>
@@ -33690,8 +35107,8 @@
           </a:p>
         </p:txBody>
       </p:sp>
-      <mc:AlternateContent xmlns:mc="http://schemas.openxmlformats.org/markup-compatibility/2006">
-        <mc:Choice xmlns:a14="http://schemas.microsoft.com/office/drawing/2010/main" Requires="a14">
+      <mc:AlternateContent xmlns:mc="http://schemas.openxmlformats.org/markup-compatibility/2006" xmlns:a14="http://schemas.microsoft.com/office/drawing/2010/main">
+        <mc:Choice Requires="a14">
           <p:sp>
             <p:nvSpPr>
               <p:cNvPr id="3" name="Content Placeholder 2">
@@ -34537,7 +35954,7 @@
             </p:txBody>
           </p:sp>
         </mc:Choice>
-        <mc:Fallback>
+        <mc:Fallback xmlns="">
           <p:sp>
             <p:nvSpPr>
               <p:cNvPr id="3" name="Content Placeholder 2">
@@ -34590,7 +36007,7 @@
 </p:sld>
 </file>
 
-<file path=ppt/slides/slide81.xml><?xml version="1.0" encoding="utf-8"?>
+<file path=ppt/slides/slide82.xml><?xml version="1.0" encoding="utf-8"?>
 <p:sld xmlns:a="http://schemas.openxmlformats.org/drawingml/2006/main" xmlns:r="http://schemas.openxmlformats.org/officeDocument/2006/relationships" xmlns:p="http://schemas.openxmlformats.org/presentationml/2006/main">
   <p:cSld>
     <p:spTree>
@@ -34646,8 +36063,8 @@
           </a:p>
         </p:txBody>
       </p:sp>
-      <mc:AlternateContent xmlns:mc="http://schemas.openxmlformats.org/markup-compatibility/2006">
-        <mc:Choice xmlns:a14="http://schemas.microsoft.com/office/drawing/2010/main" Requires="a14">
+      <mc:AlternateContent xmlns:mc="http://schemas.openxmlformats.org/markup-compatibility/2006" xmlns:a14="http://schemas.microsoft.com/office/drawing/2010/main">
+        <mc:Choice Requires="a14">
           <p:sp>
             <p:nvSpPr>
               <p:cNvPr id="3" name="Content Placeholder 2">
@@ -35846,7 +37263,7 @@
             </p:txBody>
           </p:sp>
         </mc:Choice>
-        <mc:Fallback>
+        <mc:Fallback xmlns="">
           <p:sp>
             <p:nvSpPr>
               <p:cNvPr id="3" name="Content Placeholder 2">
@@ -35899,7 +37316,7 @@
 </p:sld>
 </file>
 
-<file path=ppt/slides/slide82.xml><?xml version="1.0" encoding="utf-8"?>
+<file path=ppt/slides/slide83.xml><?xml version="1.0" encoding="utf-8"?>
 <p:sld xmlns:a="http://schemas.openxmlformats.org/drawingml/2006/main" xmlns:r="http://schemas.openxmlformats.org/officeDocument/2006/relationships" xmlns:p="http://schemas.openxmlformats.org/presentationml/2006/main">
   <p:cSld>
     <p:spTree>
@@ -35958,8 +37375,8 @@
           </a:p>
         </p:txBody>
       </p:sp>
-      <mc:AlternateContent xmlns:mc="http://schemas.openxmlformats.org/markup-compatibility/2006">
-        <mc:Choice xmlns:a14="http://schemas.microsoft.com/office/drawing/2010/main" Requires="a14">
+      <mc:AlternateContent xmlns:mc="http://schemas.openxmlformats.org/markup-compatibility/2006" xmlns:a14="http://schemas.microsoft.com/office/drawing/2010/main">
+        <mc:Choice Requires="a14">
           <p:sp>
             <p:nvSpPr>
               <p:cNvPr id="3" name="Content Placeholder 2">
@@ -36716,7 +38133,7 @@
             </p:txBody>
           </p:sp>
         </mc:Choice>
-        <mc:Fallback>
+        <mc:Fallback xmlns="">
           <p:sp>
             <p:nvSpPr>
               <p:cNvPr id="3" name="Content Placeholder 2">
@@ -36769,7 +38186,7 @@
 </p:sld>
 </file>
 
-<file path=ppt/slides/slide83.xml><?xml version="1.0" encoding="utf-8"?>
+<file path=ppt/slides/slide84.xml><?xml version="1.0" encoding="utf-8"?>
 <p:sld xmlns:a="http://schemas.openxmlformats.org/drawingml/2006/main" xmlns:r="http://schemas.openxmlformats.org/officeDocument/2006/relationships" xmlns:p="http://schemas.openxmlformats.org/presentationml/2006/main">
   <p:cSld>
     <p:spTree>
@@ -36822,8 +38239,8 @@
           </a:p>
         </p:txBody>
       </p:sp>
-      <mc:AlternateContent xmlns:mc="http://schemas.openxmlformats.org/markup-compatibility/2006">
-        <mc:Choice xmlns:a14="http://schemas.microsoft.com/office/drawing/2010/main" Requires="a14">
+      <mc:AlternateContent xmlns:mc="http://schemas.openxmlformats.org/markup-compatibility/2006" xmlns:a14="http://schemas.microsoft.com/office/drawing/2010/main">
+        <mc:Choice Requires="a14">
           <p:sp>
             <p:nvSpPr>
               <p:cNvPr id="3" name="Content Placeholder 2">
@@ -38098,7 +39515,7 @@
             </p:txBody>
           </p:sp>
         </mc:Choice>
-        <mc:Fallback>
+        <mc:Fallback xmlns="">
           <p:sp>
             <p:nvSpPr>
               <p:cNvPr id="3" name="Content Placeholder 2">
@@ -38151,7 +39568,7 @@
 </p:sld>
 </file>
 
-<file path=ppt/slides/slide84.xml><?xml version="1.0" encoding="utf-8"?>
+<file path=ppt/slides/slide85.xml><?xml version="1.0" encoding="utf-8"?>
 <p:sld xmlns:a="http://schemas.openxmlformats.org/drawingml/2006/main" xmlns:r="http://schemas.openxmlformats.org/officeDocument/2006/relationships" xmlns:p="http://schemas.openxmlformats.org/presentationml/2006/main">
   <p:cSld>
     <p:spTree>
@@ -38210,8 +39627,8 @@
           </a:p>
         </p:txBody>
       </p:sp>
-      <mc:AlternateContent xmlns:mc="http://schemas.openxmlformats.org/markup-compatibility/2006">
-        <mc:Choice xmlns:a14="http://schemas.microsoft.com/office/drawing/2010/main" Requires="a14">
+      <mc:AlternateContent xmlns:mc="http://schemas.openxmlformats.org/markup-compatibility/2006" xmlns:a14="http://schemas.microsoft.com/office/drawing/2010/main">
+        <mc:Choice Requires="a14">
           <p:sp>
             <p:nvSpPr>
               <p:cNvPr id="3" name="Content Placeholder 2">
@@ -39498,13 +40915,7 @@
                           <a:rPr lang="en-US" i="1">
                             <a:latin typeface="Cambria Math" panose="02040503050406030204" pitchFamily="18" charset="0"/>
                           </a:rPr>
-                          <m:t>𝐵</m:t>
-                        </m:r>
-                        <m:r>
-                          <a:rPr lang="en-US" i="1">
-                            <a:latin typeface="Cambria Math" panose="02040503050406030204" pitchFamily="18" charset="0"/>
-                          </a:rPr>
-                          <m:t>𝐶</m:t>
+                          <m:t>𝐵𝐶</m:t>
                         </m:r>
                       </m:e>
                     </m:acc>
@@ -39961,7 +41372,7 @@
             </p:txBody>
           </p:sp>
         </mc:Choice>
-        <mc:Fallback>
+        <mc:Fallback xmlns="">
           <p:sp>
             <p:nvSpPr>
               <p:cNvPr id="3" name="Content Placeholder 2">
@@ -40014,7 +41425,7 @@
 </p:sld>
 </file>
 
-<file path=ppt/slides/slide85.xml><?xml version="1.0" encoding="utf-8"?>
+<file path=ppt/slides/slide86.xml><?xml version="1.0" encoding="utf-8"?>
 <p:sld xmlns:a="http://schemas.openxmlformats.org/drawingml/2006/main" xmlns:r="http://schemas.openxmlformats.org/officeDocument/2006/relationships" xmlns:p="http://schemas.openxmlformats.org/presentationml/2006/main">
   <p:cSld>
     <p:spTree>
@@ -40161,7 +41572,7 @@
 </p:sld>
 </file>
 
-<file path=ppt/slides/slide86.xml><?xml version="1.0" encoding="utf-8"?>
+<file path=ppt/slides/slide87.xml><?xml version="1.0" encoding="utf-8"?>
 <p:sld xmlns:a="http://schemas.openxmlformats.org/drawingml/2006/main" xmlns:r="http://schemas.openxmlformats.org/officeDocument/2006/relationships" xmlns:p="http://schemas.openxmlformats.org/presentationml/2006/main">
   <p:cSld>
     <p:spTree>
@@ -40328,15 +41739,7 @@
             </a:r>
             <a:r>
               <a:rPr lang="en-US" dirty="0" err="1"/>
-              <a:t>queue</a:t>
-            </a:r>
-            <a:r>
-              <a:rPr lang="en-US" err="1"/>
-              <a:t>_</a:t>
-            </a:r>
-            <a:r>
-              <a:rPr lang="en-US"/>
-              <a:t>stack</a:t>
+              <a:t>queue_stack</a:t>
             </a:r>
             <a:endParaRPr lang="en-US" dirty="0"/>
           </a:p>
@@ -40355,7 +41758,7 @@
 </p:sld>
 </file>
 
-<file path=ppt/slides/slide87.xml><?xml version="1.0" encoding="utf-8"?>
+<file path=ppt/slides/slide88.xml><?xml version="1.0" encoding="utf-8"?>
 <p:sld xmlns:a="http://schemas.openxmlformats.org/drawingml/2006/main" xmlns:r="http://schemas.openxmlformats.org/officeDocument/2006/relationships" xmlns:p="http://schemas.openxmlformats.org/presentationml/2006/main">
   <p:cSld>
     <p:spTree>
@@ -40544,6 +41947,93 @@
     <p:extLst>
       <p:ext uri="{BB962C8B-B14F-4D97-AF65-F5344CB8AC3E}">
         <p14:creationId xmlns:p14="http://schemas.microsoft.com/office/powerpoint/2010/main" val="638710185"/>
+      </p:ext>
+    </p:extLst>
+  </p:cSld>
+  <p:clrMapOvr>
+    <a:masterClrMapping/>
+  </p:clrMapOvr>
+</p:sld>
+</file>
+
+<file path=ppt/slides/slide89.xml><?xml version="1.0" encoding="utf-8"?>
+<p:sld xmlns:a="http://schemas.openxmlformats.org/drawingml/2006/main" xmlns:r="http://schemas.openxmlformats.org/officeDocument/2006/relationships" xmlns:p="http://schemas.openxmlformats.org/presentationml/2006/main">
+  <p:cSld>
+    <p:spTree>
+      <p:nvGrpSpPr>
+        <p:cNvPr id="1" name=""/>
+        <p:cNvGrpSpPr/>
+        <p:nvPr/>
+      </p:nvGrpSpPr>
+      <p:grpSpPr>
+        <a:xfrm>
+          <a:off x="0" y="0"/>
+          <a:ext cx="0" cy="0"/>
+          <a:chOff x="0" y="0"/>
+          <a:chExt cx="0" cy="0"/>
+        </a:xfrm>
+      </p:grpSpPr>
+      <p:sp>
+        <p:nvSpPr>
+          <p:cNvPr id="2" name="Title 1">
+            <a:extLst>
+              <a:ext uri="{FF2B5EF4-FFF2-40B4-BE49-F238E27FC236}">
+                <a16:creationId xmlns:a16="http://schemas.microsoft.com/office/drawing/2014/main" id="{7349D11A-E375-E71D-07F3-EE29E1111792}"/>
+              </a:ext>
+            </a:extLst>
+          </p:cNvPr>
+          <p:cNvSpPr>
+            <a:spLocks noGrp="1"/>
+          </p:cNvSpPr>
+          <p:nvPr>
+            <p:ph type="title"/>
+          </p:nvPr>
+        </p:nvSpPr>
+        <p:spPr/>
+        <p:txBody>
+          <a:bodyPr/>
+          <a:lstStyle/>
+          <a:p>
+            <a:r>
+              <a:rPr lang="en-US" dirty="0"/>
+              <a:t>What does this program do ? Q1</a:t>
+            </a:r>
+          </a:p>
+        </p:txBody>
+      </p:sp>
+      <p:pic>
+        <p:nvPicPr>
+          <p:cNvPr id="5" name="Content Placeholder 4">
+            <a:extLst>
+              <a:ext uri="{FF2B5EF4-FFF2-40B4-BE49-F238E27FC236}">
+                <a16:creationId xmlns:a16="http://schemas.microsoft.com/office/drawing/2014/main" id="{F41AE1CA-0CED-FC52-B3A9-B263513E5F35}"/>
+              </a:ext>
+            </a:extLst>
+          </p:cNvPr>
+          <p:cNvPicPr>
+            <a:picLocks noGrp="1" noChangeAspect="1"/>
+          </p:cNvPicPr>
+          <p:nvPr>
+            <p:ph idx="1"/>
+          </p:nvPr>
+        </p:nvPicPr>
+        <p:blipFill>
+          <a:blip r:embed="rId2"/>
+          <a:stretch>
+            <a:fillRect/>
+          </a:stretch>
+        </p:blipFill>
+        <p:spPr>
+          <a:xfrm>
+            <a:off x="1426062" y="1690688"/>
+            <a:ext cx="4036690" cy="4213159"/>
+          </a:xfrm>
+        </p:spPr>
+      </p:pic>
+    </p:spTree>
+    <p:extLst>
+      <p:ext uri="{BB962C8B-B14F-4D97-AF65-F5344CB8AC3E}">
+        <p14:creationId xmlns:p14="http://schemas.microsoft.com/office/powerpoint/2010/main" val="3510970545"/>
       </p:ext>
     </p:extLst>
   </p:cSld>
@@ -40751,6 +42241,1738 @@
     <p:extLst>
       <p:ext uri="{BB962C8B-B14F-4D97-AF65-F5344CB8AC3E}">
         <p14:creationId xmlns:p14="http://schemas.microsoft.com/office/powerpoint/2010/main" val="2745915873"/>
+      </p:ext>
+    </p:extLst>
+  </p:cSld>
+  <p:clrMapOvr>
+    <a:masterClrMapping/>
+  </p:clrMapOvr>
+</p:sld>
+</file>
+
+<file path=ppt/slides/slide90.xml><?xml version="1.0" encoding="utf-8"?>
+<p:sld xmlns:a="http://schemas.openxmlformats.org/drawingml/2006/main" xmlns:r="http://schemas.openxmlformats.org/officeDocument/2006/relationships" xmlns:p="http://schemas.openxmlformats.org/presentationml/2006/main">
+  <p:cSld>
+    <p:spTree>
+      <p:nvGrpSpPr>
+        <p:cNvPr id="1" name="">
+          <a:extLst>
+            <a:ext uri="{FF2B5EF4-FFF2-40B4-BE49-F238E27FC236}">
+              <a16:creationId xmlns:a16="http://schemas.microsoft.com/office/drawing/2014/main" id="{B062178D-935B-AAEE-36BA-F87AA98BAA92}"/>
+            </a:ext>
+          </a:extLst>
+        </p:cNvPr>
+        <p:cNvGrpSpPr/>
+        <p:nvPr/>
+      </p:nvGrpSpPr>
+      <p:grpSpPr>
+        <a:xfrm>
+          <a:off x="0" y="0"/>
+          <a:ext cx="0" cy="0"/>
+          <a:chOff x="0" y="0"/>
+          <a:chExt cx="0" cy="0"/>
+        </a:xfrm>
+      </p:grpSpPr>
+      <p:sp>
+        <p:nvSpPr>
+          <p:cNvPr id="2" name="Title 1">
+            <a:extLst>
+              <a:ext uri="{FF2B5EF4-FFF2-40B4-BE49-F238E27FC236}">
+                <a16:creationId xmlns:a16="http://schemas.microsoft.com/office/drawing/2014/main" id="{CE6F76CD-D406-A389-02FF-0BA92261C88F}"/>
+              </a:ext>
+            </a:extLst>
+          </p:cNvPr>
+          <p:cNvSpPr>
+            <a:spLocks noGrp="1"/>
+          </p:cNvSpPr>
+          <p:nvPr>
+            <p:ph type="title"/>
+          </p:nvPr>
+        </p:nvSpPr>
+        <p:spPr/>
+        <p:txBody>
+          <a:bodyPr/>
+          <a:lstStyle/>
+          <a:p>
+            <a:r>
+              <a:rPr lang="en-US" dirty="0"/>
+              <a:t>What does this program do ? A1</a:t>
+            </a:r>
+          </a:p>
+        </p:txBody>
+      </p:sp>
+      <p:graphicFrame>
+        <p:nvGraphicFramePr>
+          <p:cNvPr id="6" name="Content Placeholder 5">
+            <a:extLst>
+              <a:ext uri="{FF2B5EF4-FFF2-40B4-BE49-F238E27FC236}">
+                <a16:creationId xmlns:a16="http://schemas.microsoft.com/office/drawing/2014/main" id="{48ECFA53-052C-D6F6-6B28-122C1A2DBAD8}"/>
+              </a:ext>
+            </a:extLst>
+          </p:cNvPr>
+          <p:cNvGraphicFramePr>
+            <a:graphicFrameLocks noGrp="1"/>
+          </p:cNvGraphicFramePr>
+          <p:nvPr>
+            <p:ph idx="1"/>
+            <p:extLst>
+              <p:ext uri="{D42A27DB-BD31-4B8C-83A1-F6EECF244321}">
+                <p14:modId xmlns:p14="http://schemas.microsoft.com/office/powerpoint/2010/main" val="1003421758"/>
+              </p:ext>
+            </p:extLst>
+          </p:nvPr>
+        </p:nvGraphicFramePr>
+        <p:xfrm>
+          <a:off x="1224455" y="2948151"/>
+          <a:ext cx="4001814" cy="2774736"/>
+        </p:xfrm>
+        <a:graphic>
+          <a:graphicData uri="http://schemas.openxmlformats.org/drawingml/2006/table">
+            <a:tbl>
+              <a:tblPr firstRow="1" bandRow="1">
+                <a:tableStyleId>{5C22544A-7EE6-4342-B048-85BDC9FD1C3A}</a:tableStyleId>
+              </a:tblPr>
+              <a:tblGrid>
+                <a:gridCol w="1333938">
+                  <a:extLst>
+                    <a:ext uri="{9D8B030D-6E8A-4147-A177-3AD203B41FA5}">
+                      <a16:colId xmlns:a16="http://schemas.microsoft.com/office/drawing/2014/main" val="563773428"/>
+                    </a:ext>
+                  </a:extLst>
+                </a:gridCol>
+                <a:gridCol w="1453930">
+                  <a:extLst>
+                    <a:ext uri="{9D8B030D-6E8A-4147-A177-3AD203B41FA5}">
+                      <a16:colId xmlns:a16="http://schemas.microsoft.com/office/drawing/2014/main" val="2982123843"/>
+                    </a:ext>
+                  </a:extLst>
+                </a:gridCol>
+                <a:gridCol w="1213946">
+                  <a:extLst>
+                    <a:ext uri="{9D8B030D-6E8A-4147-A177-3AD203B41FA5}">
+                      <a16:colId xmlns:a16="http://schemas.microsoft.com/office/drawing/2014/main" val="905214871"/>
+                    </a:ext>
+                  </a:extLst>
+                </a:gridCol>
+              </a:tblGrid>
+              <a:tr h="462456">
+                <a:tc>
+                  <a:txBody>
+                    <a:bodyPr/>
+                    <a:lstStyle/>
+                    <a:p>
+                      <a:pPr algn="ctr"/>
+                      <a:r>
+                        <a:rPr lang="en-US" dirty="0" err="1"/>
+                        <a:t>i</a:t>
+                      </a:r>
+                      <a:endParaRPr lang="en-US" dirty="0"/>
+                    </a:p>
+                  </a:txBody>
+                  <a:tcPr/>
+                </a:tc>
+                <a:tc>
+                  <a:txBody>
+                    <a:bodyPr/>
+                    <a:lstStyle/>
+                    <a:p>
+                      <a:pPr algn="ctr"/>
+                      <a:r>
+                        <a:rPr lang="en-US" dirty="0"/>
+                        <a:t>A[</a:t>
+                      </a:r>
+                      <a:r>
+                        <a:rPr lang="en-US" dirty="0" err="1"/>
+                        <a:t>i</a:t>
+                      </a:r>
+                      <a:r>
+                        <a:rPr lang="en-US" dirty="0"/>
+                        <a:t>] : Before</a:t>
+                      </a:r>
+                    </a:p>
+                  </a:txBody>
+                  <a:tcPr/>
+                </a:tc>
+                <a:tc>
+                  <a:txBody>
+                    <a:bodyPr/>
+                    <a:lstStyle/>
+                    <a:p>
+                      <a:pPr algn="ctr"/>
+                      <a:r>
+                        <a:rPr lang="en-US" dirty="0"/>
+                        <a:t>A[</a:t>
+                      </a:r>
+                      <a:r>
+                        <a:rPr lang="en-US" dirty="0" err="1"/>
+                        <a:t>i</a:t>
+                      </a:r>
+                      <a:r>
+                        <a:rPr lang="en-US" dirty="0"/>
+                        <a:t>] : After</a:t>
+                      </a:r>
+                    </a:p>
+                  </a:txBody>
+                  <a:tcPr/>
+                </a:tc>
+                <a:extLst>
+                  <a:ext uri="{0D108BD9-81ED-4DB2-BD59-A6C34878D82A}">
+                    <a16:rowId xmlns:a16="http://schemas.microsoft.com/office/drawing/2014/main" val="156903781"/>
+                  </a:ext>
+                </a:extLst>
+              </a:tr>
+              <a:tr h="462456">
+                <a:tc>
+                  <a:txBody>
+                    <a:bodyPr/>
+                    <a:lstStyle/>
+                    <a:p>
+                      <a:r>
+                        <a:rPr lang="en-US" dirty="0"/>
+                        <a:t>0</a:t>
+                      </a:r>
+                    </a:p>
+                  </a:txBody>
+                  <a:tcPr/>
+                </a:tc>
+                <a:tc>
+                  <a:txBody>
+                    <a:bodyPr/>
+                    <a:lstStyle/>
+                    <a:p>
+                      <a:r>
+                        <a:rPr lang="en-US" dirty="0"/>
+                        <a:t>1</a:t>
+                      </a:r>
+                    </a:p>
+                  </a:txBody>
+                  <a:tcPr/>
+                </a:tc>
+                <a:tc>
+                  <a:txBody>
+                    <a:bodyPr/>
+                    <a:lstStyle/>
+                    <a:p>
+                      <a:r>
+                        <a:rPr lang="en-US" dirty="0"/>
+                        <a:t>1</a:t>
+                      </a:r>
+                    </a:p>
+                  </a:txBody>
+                  <a:tcPr/>
+                </a:tc>
+                <a:extLst>
+                  <a:ext uri="{0D108BD9-81ED-4DB2-BD59-A6C34878D82A}">
+                    <a16:rowId xmlns:a16="http://schemas.microsoft.com/office/drawing/2014/main" val="1004111627"/>
+                  </a:ext>
+                </a:extLst>
+              </a:tr>
+              <a:tr h="462456">
+                <a:tc>
+                  <a:txBody>
+                    <a:bodyPr/>
+                    <a:lstStyle/>
+                    <a:p>
+                      <a:r>
+                        <a:rPr lang="en-US" dirty="0"/>
+                        <a:t>1</a:t>
+                      </a:r>
+                    </a:p>
+                  </a:txBody>
+                  <a:tcPr/>
+                </a:tc>
+                <a:tc>
+                  <a:txBody>
+                    <a:bodyPr/>
+                    <a:lstStyle/>
+                    <a:p>
+                      <a:r>
+                        <a:rPr lang="en-US" dirty="0"/>
+                        <a:t>2</a:t>
+                      </a:r>
+                    </a:p>
+                  </a:txBody>
+                  <a:tcPr/>
+                </a:tc>
+                <a:tc>
+                  <a:txBody>
+                    <a:bodyPr/>
+                    <a:lstStyle/>
+                    <a:p>
+                      <a:r>
+                        <a:rPr lang="en-US" dirty="0"/>
+                        <a:t>3</a:t>
+                      </a:r>
+                    </a:p>
+                  </a:txBody>
+                  <a:tcPr/>
+                </a:tc>
+                <a:extLst>
+                  <a:ext uri="{0D108BD9-81ED-4DB2-BD59-A6C34878D82A}">
+                    <a16:rowId xmlns:a16="http://schemas.microsoft.com/office/drawing/2014/main" val="4019452181"/>
+                  </a:ext>
+                </a:extLst>
+              </a:tr>
+              <a:tr h="462456">
+                <a:tc>
+                  <a:txBody>
+                    <a:bodyPr/>
+                    <a:lstStyle/>
+                    <a:p>
+                      <a:r>
+                        <a:rPr lang="en-US" dirty="0"/>
+                        <a:t>2</a:t>
+                      </a:r>
+                    </a:p>
+                  </a:txBody>
+                  <a:tcPr/>
+                </a:tc>
+                <a:tc>
+                  <a:txBody>
+                    <a:bodyPr/>
+                    <a:lstStyle/>
+                    <a:p>
+                      <a:r>
+                        <a:rPr lang="en-US" dirty="0"/>
+                        <a:t>3</a:t>
+                      </a:r>
+                    </a:p>
+                  </a:txBody>
+                  <a:tcPr/>
+                </a:tc>
+                <a:tc>
+                  <a:txBody>
+                    <a:bodyPr/>
+                    <a:lstStyle/>
+                    <a:p>
+                      <a:r>
+                        <a:rPr lang="en-US" dirty="0"/>
+                        <a:t>5</a:t>
+                      </a:r>
+                    </a:p>
+                  </a:txBody>
+                  <a:tcPr/>
+                </a:tc>
+                <a:extLst>
+                  <a:ext uri="{0D108BD9-81ED-4DB2-BD59-A6C34878D82A}">
+                    <a16:rowId xmlns:a16="http://schemas.microsoft.com/office/drawing/2014/main" val="4092189348"/>
+                  </a:ext>
+                </a:extLst>
+              </a:tr>
+              <a:tr h="462456">
+                <a:tc>
+                  <a:txBody>
+                    <a:bodyPr/>
+                    <a:lstStyle/>
+                    <a:p>
+                      <a:r>
+                        <a:rPr lang="en-US" dirty="0"/>
+                        <a:t>3</a:t>
+                      </a:r>
+                    </a:p>
+                  </a:txBody>
+                  <a:tcPr/>
+                </a:tc>
+                <a:tc>
+                  <a:txBody>
+                    <a:bodyPr/>
+                    <a:lstStyle/>
+                    <a:p>
+                      <a:r>
+                        <a:rPr lang="en-US" dirty="0"/>
+                        <a:t>4</a:t>
+                      </a:r>
+                    </a:p>
+                  </a:txBody>
+                  <a:tcPr/>
+                </a:tc>
+                <a:tc>
+                  <a:txBody>
+                    <a:bodyPr/>
+                    <a:lstStyle/>
+                    <a:p>
+                      <a:r>
+                        <a:rPr lang="en-US" dirty="0"/>
+                        <a:t>7</a:t>
+                      </a:r>
+                    </a:p>
+                  </a:txBody>
+                  <a:tcPr/>
+                </a:tc>
+                <a:extLst>
+                  <a:ext uri="{0D108BD9-81ED-4DB2-BD59-A6C34878D82A}">
+                    <a16:rowId xmlns:a16="http://schemas.microsoft.com/office/drawing/2014/main" val="2830260239"/>
+                  </a:ext>
+                </a:extLst>
+              </a:tr>
+              <a:tr h="462456">
+                <a:tc>
+                  <a:txBody>
+                    <a:bodyPr/>
+                    <a:lstStyle/>
+                    <a:p>
+                      <a:r>
+                        <a:rPr lang="en-US" dirty="0"/>
+                        <a:t>4</a:t>
+                      </a:r>
+                    </a:p>
+                  </a:txBody>
+                  <a:tcPr/>
+                </a:tc>
+                <a:tc>
+                  <a:txBody>
+                    <a:bodyPr/>
+                    <a:lstStyle/>
+                    <a:p>
+                      <a:r>
+                        <a:rPr lang="en-US" dirty="0"/>
+                        <a:t>5</a:t>
+                      </a:r>
+                    </a:p>
+                  </a:txBody>
+                  <a:tcPr/>
+                </a:tc>
+                <a:tc>
+                  <a:txBody>
+                    <a:bodyPr/>
+                    <a:lstStyle/>
+                    <a:p>
+                      <a:r>
+                        <a:rPr lang="en-US" dirty="0"/>
+                        <a:t>9</a:t>
+                      </a:r>
+                    </a:p>
+                  </a:txBody>
+                  <a:tcPr/>
+                </a:tc>
+                <a:extLst>
+                  <a:ext uri="{0D108BD9-81ED-4DB2-BD59-A6C34878D82A}">
+                    <a16:rowId xmlns:a16="http://schemas.microsoft.com/office/drawing/2014/main" val="3696806729"/>
+                  </a:ext>
+                </a:extLst>
+              </a:tr>
+            </a:tbl>
+          </a:graphicData>
+        </a:graphic>
+      </p:graphicFrame>
+      <p:pic>
+        <p:nvPicPr>
+          <p:cNvPr id="7" name="Content Placeholder 4">
+            <a:extLst>
+              <a:ext uri="{FF2B5EF4-FFF2-40B4-BE49-F238E27FC236}">
+                <a16:creationId xmlns:a16="http://schemas.microsoft.com/office/drawing/2014/main" id="{F0E50695-BDC5-0370-1DB9-2A32436F217E}"/>
+              </a:ext>
+            </a:extLst>
+          </p:cNvPr>
+          <p:cNvPicPr>
+            <a:picLocks noChangeAspect="1"/>
+          </p:cNvPicPr>
+          <p:nvPr/>
+        </p:nvPicPr>
+        <p:blipFill>
+          <a:blip r:embed="rId2"/>
+          <a:stretch>
+            <a:fillRect/>
+          </a:stretch>
+        </p:blipFill>
+        <p:spPr>
+          <a:xfrm>
+            <a:off x="6415848" y="1675557"/>
+            <a:ext cx="4036690" cy="4213159"/>
+          </a:xfrm>
+          <a:prstGeom prst="rect">
+            <a:avLst/>
+          </a:prstGeom>
+        </p:spPr>
+      </p:pic>
+      <p:sp>
+        <p:nvSpPr>
+          <p:cNvPr id="12" name="TextBox 11">
+            <a:extLst>
+              <a:ext uri="{FF2B5EF4-FFF2-40B4-BE49-F238E27FC236}">
+                <a16:creationId xmlns:a16="http://schemas.microsoft.com/office/drawing/2014/main" id="{945E9F79-29BB-4CDA-46A4-57558B564644}"/>
+              </a:ext>
+            </a:extLst>
+          </p:cNvPr>
+          <p:cNvSpPr txBox="1"/>
+          <p:nvPr/>
+        </p:nvSpPr>
+        <p:spPr>
+          <a:xfrm>
+            <a:off x="1224455" y="2088587"/>
+            <a:ext cx="4124653" cy="461665"/>
+          </a:xfrm>
+          <a:prstGeom prst="rect">
+            <a:avLst/>
+          </a:prstGeom>
+          <a:noFill/>
+        </p:spPr>
+        <p:txBody>
+          <a:bodyPr wrap="square">
+            <a:spAutoFit/>
+          </a:bodyPr>
+          <a:lstStyle/>
+          <a:p>
+            <a:r>
+              <a:rPr lang="en-US" sz="2400" b="1" dirty="0"/>
+              <a:t>9 7 5 3 1</a:t>
+            </a:r>
+            <a:endParaRPr lang="en-US" sz="2400" dirty="0"/>
+          </a:p>
+        </p:txBody>
+      </p:sp>
+    </p:spTree>
+    <p:extLst>
+      <p:ext uri="{BB962C8B-B14F-4D97-AF65-F5344CB8AC3E}">
+        <p14:creationId xmlns:p14="http://schemas.microsoft.com/office/powerpoint/2010/main" val="3077207006"/>
+      </p:ext>
+    </p:extLst>
+  </p:cSld>
+  <p:clrMapOvr>
+    <a:masterClrMapping/>
+  </p:clrMapOvr>
+</p:sld>
+</file>
+
+<file path=ppt/slides/slide91.xml><?xml version="1.0" encoding="utf-8"?>
+<p:sld xmlns:a="http://schemas.openxmlformats.org/drawingml/2006/main" xmlns:r="http://schemas.openxmlformats.org/officeDocument/2006/relationships" xmlns:p="http://schemas.openxmlformats.org/presentationml/2006/main">
+  <p:cSld>
+    <p:spTree>
+      <p:nvGrpSpPr>
+        <p:cNvPr id="1" name=""/>
+        <p:cNvGrpSpPr/>
+        <p:nvPr/>
+      </p:nvGrpSpPr>
+      <p:grpSpPr>
+        <a:xfrm>
+          <a:off x="0" y="0"/>
+          <a:ext cx="0" cy="0"/>
+          <a:chOff x="0" y="0"/>
+          <a:chExt cx="0" cy="0"/>
+        </a:xfrm>
+      </p:grpSpPr>
+      <p:sp>
+        <p:nvSpPr>
+          <p:cNvPr id="2" name="Title 1">
+            <a:extLst>
+              <a:ext uri="{FF2B5EF4-FFF2-40B4-BE49-F238E27FC236}">
+                <a16:creationId xmlns:a16="http://schemas.microsoft.com/office/drawing/2014/main" id="{693160C2-3FE9-DE1C-F670-2471C6908176}"/>
+              </a:ext>
+            </a:extLst>
+          </p:cNvPr>
+          <p:cNvSpPr>
+            <a:spLocks noGrp="1"/>
+          </p:cNvSpPr>
+          <p:nvPr>
+            <p:ph type="title"/>
+          </p:nvPr>
+        </p:nvSpPr>
+        <p:spPr/>
+        <p:txBody>
+          <a:bodyPr/>
+          <a:lstStyle/>
+          <a:p>
+            <a:r>
+              <a:rPr lang="en-US" dirty="0"/>
+              <a:t>What does this program do ? Q2</a:t>
+            </a:r>
+          </a:p>
+        </p:txBody>
+      </p:sp>
+      <p:pic>
+        <p:nvPicPr>
+          <p:cNvPr id="5" name="Content Placeholder 4">
+            <a:extLst>
+              <a:ext uri="{FF2B5EF4-FFF2-40B4-BE49-F238E27FC236}">
+                <a16:creationId xmlns:a16="http://schemas.microsoft.com/office/drawing/2014/main" id="{13A649AB-679F-53E7-0286-70971B8EF844}"/>
+              </a:ext>
+            </a:extLst>
+          </p:cNvPr>
+          <p:cNvPicPr>
+            <a:picLocks noGrp="1" noChangeAspect="1"/>
+          </p:cNvPicPr>
+          <p:nvPr>
+            <p:ph idx="1"/>
+          </p:nvPr>
+        </p:nvPicPr>
+        <p:blipFill>
+          <a:blip r:embed="rId2"/>
+          <a:stretch>
+            <a:fillRect/>
+          </a:stretch>
+        </p:blipFill>
+        <p:spPr>
+          <a:xfrm>
+            <a:off x="984934" y="1690688"/>
+            <a:ext cx="4516662" cy="4142553"/>
+          </a:xfrm>
+        </p:spPr>
+      </p:pic>
+    </p:spTree>
+    <p:extLst>
+      <p:ext uri="{BB962C8B-B14F-4D97-AF65-F5344CB8AC3E}">
+        <p14:creationId xmlns:p14="http://schemas.microsoft.com/office/powerpoint/2010/main" val="1674324199"/>
+      </p:ext>
+    </p:extLst>
+  </p:cSld>
+  <p:clrMapOvr>
+    <a:masterClrMapping/>
+  </p:clrMapOvr>
+</p:sld>
+</file>
+
+<file path=ppt/slides/slide92.xml><?xml version="1.0" encoding="utf-8"?>
+<p:sld xmlns:a="http://schemas.openxmlformats.org/drawingml/2006/main" xmlns:r="http://schemas.openxmlformats.org/officeDocument/2006/relationships" xmlns:p="http://schemas.openxmlformats.org/presentationml/2006/main">
+  <p:cSld>
+    <p:spTree>
+      <p:nvGrpSpPr>
+        <p:cNvPr id="1" name="">
+          <a:extLst>
+            <a:ext uri="{FF2B5EF4-FFF2-40B4-BE49-F238E27FC236}">
+              <a16:creationId xmlns:a16="http://schemas.microsoft.com/office/drawing/2014/main" id="{9F47532A-6F5A-F03B-491E-8D8610979A0B}"/>
+            </a:ext>
+          </a:extLst>
+        </p:cNvPr>
+        <p:cNvGrpSpPr/>
+        <p:nvPr/>
+      </p:nvGrpSpPr>
+      <p:grpSpPr>
+        <a:xfrm>
+          <a:off x="0" y="0"/>
+          <a:ext cx="0" cy="0"/>
+          <a:chOff x="0" y="0"/>
+          <a:chExt cx="0" cy="0"/>
+        </a:xfrm>
+      </p:grpSpPr>
+      <p:sp>
+        <p:nvSpPr>
+          <p:cNvPr id="2" name="Title 1">
+            <a:extLst>
+              <a:ext uri="{FF2B5EF4-FFF2-40B4-BE49-F238E27FC236}">
+                <a16:creationId xmlns:a16="http://schemas.microsoft.com/office/drawing/2014/main" id="{3F784C87-8A76-0A64-FF44-67BE47DDE589}"/>
+              </a:ext>
+            </a:extLst>
+          </p:cNvPr>
+          <p:cNvSpPr>
+            <a:spLocks noGrp="1"/>
+          </p:cNvSpPr>
+          <p:nvPr>
+            <p:ph type="title"/>
+          </p:nvPr>
+        </p:nvSpPr>
+        <p:spPr/>
+        <p:txBody>
+          <a:bodyPr/>
+          <a:lstStyle/>
+          <a:p>
+            <a:r>
+              <a:rPr lang="en-US" dirty="0"/>
+              <a:t>What does this program do ? A2</a:t>
+            </a:r>
+          </a:p>
+        </p:txBody>
+      </p:sp>
+      <p:sp>
+        <p:nvSpPr>
+          <p:cNvPr id="4" name="Content Placeholder 3">
+            <a:extLst>
+              <a:ext uri="{FF2B5EF4-FFF2-40B4-BE49-F238E27FC236}">
+                <a16:creationId xmlns:a16="http://schemas.microsoft.com/office/drawing/2014/main" id="{C918AF0C-177A-2287-B125-733572E30D38}"/>
+              </a:ext>
+            </a:extLst>
+          </p:cNvPr>
+          <p:cNvSpPr>
+            <a:spLocks noGrp="1"/>
+          </p:cNvSpPr>
+          <p:nvPr>
+            <p:ph idx="1"/>
+          </p:nvPr>
+        </p:nvSpPr>
+        <p:spPr/>
+        <p:txBody>
+          <a:bodyPr/>
+          <a:lstStyle/>
+          <a:p>
+            <a:pPr marL="0" indent="0">
+              <a:buNone/>
+            </a:pPr>
+            <a:r>
+              <a:rPr lang="en-US" dirty="0"/>
+              <a:t>2 4 6 8</a:t>
+            </a:r>
+          </a:p>
+          <a:p>
+            <a:pPr marL="0" indent="0">
+              <a:buNone/>
+            </a:pPr>
+            <a:endParaRPr lang="en-US" dirty="0"/>
+          </a:p>
+          <a:p>
+            <a:pPr>
+              <a:buFontTx/>
+              <a:buChar char="-"/>
+            </a:pPr>
+            <a:r>
+              <a:rPr lang="en-US" dirty="0"/>
+              <a:t>This program tried to sort</a:t>
+            </a:r>
+          </a:p>
+          <a:p>
+            <a:pPr>
+              <a:buFontTx/>
+              <a:buChar char="-"/>
+            </a:pPr>
+            <a:r>
+              <a:rPr lang="en-US" dirty="0"/>
+              <a:t>Already sorted </a:t>
+            </a:r>
+            <a:r>
+              <a:rPr lang="en-US" dirty="0">
+                <a:sym typeface="Wingdings" panose="05000000000000000000" pitchFamily="2" charset="2"/>
+              </a:rPr>
+              <a:t></a:t>
+            </a:r>
+            <a:r>
+              <a:rPr lang="en-US" dirty="0"/>
+              <a:t>Nothing happens </a:t>
+            </a:r>
+          </a:p>
+        </p:txBody>
+      </p:sp>
+      <p:pic>
+        <p:nvPicPr>
+          <p:cNvPr id="6" name="Content Placeholder 4">
+            <a:extLst>
+              <a:ext uri="{FF2B5EF4-FFF2-40B4-BE49-F238E27FC236}">
+                <a16:creationId xmlns:a16="http://schemas.microsoft.com/office/drawing/2014/main" id="{3A58DBF8-59D4-4A3D-CD6D-54C16CC7A73A}"/>
+              </a:ext>
+            </a:extLst>
+          </p:cNvPr>
+          <p:cNvPicPr>
+            <a:picLocks noChangeAspect="1"/>
+          </p:cNvPicPr>
+          <p:nvPr/>
+        </p:nvPicPr>
+        <p:blipFill>
+          <a:blip r:embed="rId2"/>
+          <a:stretch>
+            <a:fillRect/>
+          </a:stretch>
+        </p:blipFill>
+        <p:spPr>
+          <a:xfrm>
+            <a:off x="7086599" y="1825625"/>
+            <a:ext cx="4212021" cy="3863145"/>
+          </a:xfrm>
+          <a:prstGeom prst="rect">
+            <a:avLst/>
+          </a:prstGeom>
+        </p:spPr>
+      </p:pic>
+    </p:spTree>
+    <p:extLst>
+      <p:ext uri="{BB962C8B-B14F-4D97-AF65-F5344CB8AC3E}">
+        <p14:creationId xmlns:p14="http://schemas.microsoft.com/office/powerpoint/2010/main" val="14287973"/>
+      </p:ext>
+    </p:extLst>
+  </p:cSld>
+  <p:clrMapOvr>
+    <a:masterClrMapping/>
+  </p:clrMapOvr>
+</p:sld>
+</file>
+
+<file path=ppt/slides/slide93.xml><?xml version="1.0" encoding="utf-8"?>
+<p:sld xmlns:a="http://schemas.openxmlformats.org/drawingml/2006/main" xmlns:r="http://schemas.openxmlformats.org/officeDocument/2006/relationships" xmlns:p="http://schemas.openxmlformats.org/presentationml/2006/main">
+  <p:cSld>
+    <p:spTree>
+      <p:nvGrpSpPr>
+        <p:cNvPr id="1" name="">
+          <a:extLst>
+            <a:ext uri="{FF2B5EF4-FFF2-40B4-BE49-F238E27FC236}">
+              <a16:creationId xmlns:a16="http://schemas.microsoft.com/office/drawing/2014/main" id="{861DC7EA-2D17-DA29-7BE7-A16B9FCCECE4}"/>
+            </a:ext>
+          </a:extLst>
+        </p:cNvPr>
+        <p:cNvGrpSpPr/>
+        <p:nvPr/>
+      </p:nvGrpSpPr>
+      <p:grpSpPr>
+        <a:xfrm>
+          <a:off x="0" y="0"/>
+          <a:ext cx="0" cy="0"/>
+          <a:chOff x="0" y="0"/>
+          <a:chExt cx="0" cy="0"/>
+        </a:xfrm>
+      </p:grpSpPr>
+      <p:sp>
+        <p:nvSpPr>
+          <p:cNvPr id="2" name="Title 1">
+            <a:extLst>
+              <a:ext uri="{FF2B5EF4-FFF2-40B4-BE49-F238E27FC236}">
+                <a16:creationId xmlns:a16="http://schemas.microsoft.com/office/drawing/2014/main" id="{EF47385F-E344-2CA5-16FD-C3C3301D0AFA}"/>
+              </a:ext>
+            </a:extLst>
+          </p:cNvPr>
+          <p:cNvSpPr>
+            <a:spLocks noGrp="1"/>
+          </p:cNvSpPr>
+          <p:nvPr>
+            <p:ph type="title"/>
+          </p:nvPr>
+        </p:nvSpPr>
+        <p:spPr/>
+        <p:txBody>
+          <a:bodyPr/>
+          <a:lstStyle/>
+          <a:p>
+            <a:r>
+              <a:rPr lang="en-US" dirty="0"/>
+              <a:t>What does this program do ? Q3</a:t>
+            </a:r>
+          </a:p>
+        </p:txBody>
+      </p:sp>
+      <p:pic>
+        <p:nvPicPr>
+          <p:cNvPr id="7" name="Content Placeholder 6">
+            <a:extLst>
+              <a:ext uri="{FF2B5EF4-FFF2-40B4-BE49-F238E27FC236}">
+                <a16:creationId xmlns:a16="http://schemas.microsoft.com/office/drawing/2014/main" id="{8175DD1A-FC8B-A807-42A0-48613AC903EF}"/>
+              </a:ext>
+            </a:extLst>
+          </p:cNvPr>
+          <p:cNvPicPr>
+            <a:picLocks noGrp="1" noChangeAspect="1"/>
+          </p:cNvPicPr>
+          <p:nvPr>
+            <p:ph idx="1"/>
+          </p:nvPr>
+        </p:nvPicPr>
+        <p:blipFill>
+          <a:blip r:embed="rId2"/>
+          <a:stretch>
+            <a:fillRect/>
+          </a:stretch>
+        </p:blipFill>
+        <p:spPr>
+          <a:xfrm>
+            <a:off x="1138313" y="1690688"/>
+            <a:ext cx="5064006" cy="4071609"/>
+          </a:xfrm>
+        </p:spPr>
+      </p:pic>
+    </p:spTree>
+    <p:extLst>
+      <p:ext uri="{BB962C8B-B14F-4D97-AF65-F5344CB8AC3E}">
+        <p14:creationId xmlns:p14="http://schemas.microsoft.com/office/powerpoint/2010/main" val="1967275122"/>
+      </p:ext>
+    </p:extLst>
+  </p:cSld>
+  <p:clrMapOvr>
+    <a:masterClrMapping/>
+  </p:clrMapOvr>
+</p:sld>
+</file>
+
+<file path=ppt/slides/slide94.xml><?xml version="1.0" encoding="utf-8"?>
+<p:sld xmlns:a="http://schemas.openxmlformats.org/drawingml/2006/main" xmlns:r="http://schemas.openxmlformats.org/officeDocument/2006/relationships" xmlns:p="http://schemas.openxmlformats.org/presentationml/2006/main">
+  <p:cSld>
+    <p:spTree>
+      <p:nvGrpSpPr>
+        <p:cNvPr id="1" name="">
+          <a:extLst>
+            <a:ext uri="{FF2B5EF4-FFF2-40B4-BE49-F238E27FC236}">
+              <a16:creationId xmlns:a16="http://schemas.microsoft.com/office/drawing/2014/main" id="{893586C3-3556-C4E4-2F98-34D72C0EF83B}"/>
+            </a:ext>
+          </a:extLst>
+        </p:cNvPr>
+        <p:cNvGrpSpPr/>
+        <p:nvPr/>
+      </p:nvGrpSpPr>
+      <p:grpSpPr>
+        <a:xfrm>
+          <a:off x="0" y="0"/>
+          <a:ext cx="0" cy="0"/>
+          <a:chOff x="0" y="0"/>
+          <a:chExt cx="0" cy="0"/>
+        </a:xfrm>
+      </p:grpSpPr>
+      <p:sp>
+        <p:nvSpPr>
+          <p:cNvPr id="2" name="Title 1">
+            <a:extLst>
+              <a:ext uri="{FF2B5EF4-FFF2-40B4-BE49-F238E27FC236}">
+                <a16:creationId xmlns:a16="http://schemas.microsoft.com/office/drawing/2014/main" id="{E68613A8-03DC-CAC0-8256-B67ADE32A091}"/>
+              </a:ext>
+            </a:extLst>
+          </p:cNvPr>
+          <p:cNvSpPr>
+            <a:spLocks noGrp="1"/>
+          </p:cNvSpPr>
+          <p:nvPr>
+            <p:ph type="title"/>
+          </p:nvPr>
+        </p:nvSpPr>
+        <p:spPr/>
+        <p:txBody>
+          <a:bodyPr/>
+          <a:lstStyle/>
+          <a:p>
+            <a:r>
+              <a:rPr lang="en-US" dirty="0"/>
+              <a:t>What does this program do ? A3</a:t>
+            </a:r>
+          </a:p>
+        </p:txBody>
+      </p:sp>
+      <p:sp>
+        <p:nvSpPr>
+          <p:cNvPr id="4" name="Content Placeholder 3">
+            <a:extLst>
+              <a:ext uri="{FF2B5EF4-FFF2-40B4-BE49-F238E27FC236}">
+                <a16:creationId xmlns:a16="http://schemas.microsoft.com/office/drawing/2014/main" id="{A63127C6-BB4E-AE59-83D7-ECD64EB851DF}"/>
+              </a:ext>
+            </a:extLst>
+          </p:cNvPr>
+          <p:cNvSpPr>
+            <a:spLocks noGrp="1"/>
+          </p:cNvSpPr>
+          <p:nvPr>
+            <p:ph idx="1"/>
+          </p:nvPr>
+        </p:nvSpPr>
+        <p:spPr/>
+        <p:txBody>
+          <a:bodyPr>
+            <a:normAutofit fontScale="85000" lnSpcReduction="20000"/>
+          </a:bodyPr>
+          <a:lstStyle/>
+          <a:p>
+            <a:r>
+              <a:rPr lang="en-US" b="1" dirty="0"/>
+              <a:t>13</a:t>
+            </a:r>
+          </a:p>
+          <a:p>
+            <a:r>
+              <a:rPr lang="en-US" dirty="0"/>
+              <a:t>Add j only when (</a:t>
+            </a:r>
+            <a:r>
+              <a:rPr lang="en-US" dirty="0" err="1"/>
+              <a:t>i+j</a:t>
+            </a:r>
+            <a:r>
+              <a:rPr lang="en-US" dirty="0"/>
+              <a:t>) is even</a:t>
+            </a:r>
+          </a:p>
+          <a:p>
+            <a:pPr lvl="1"/>
+            <a:r>
+              <a:rPr lang="en-US" dirty="0" err="1"/>
+              <a:t>i</a:t>
+            </a:r>
+            <a:r>
+              <a:rPr lang="en-US" dirty="0"/>
+              <a:t> =1</a:t>
+            </a:r>
+          </a:p>
+          <a:p>
+            <a:pPr lvl="2"/>
+            <a:r>
+              <a:rPr lang="en-US" dirty="0"/>
+              <a:t>j=1 → 2 (even) → +1 → sum=1</a:t>
+            </a:r>
+          </a:p>
+          <a:p>
+            <a:pPr lvl="1"/>
+            <a:r>
+              <a:rPr lang="en-US" dirty="0" err="1"/>
+              <a:t>i</a:t>
+            </a:r>
+            <a:r>
+              <a:rPr lang="en-US" dirty="0"/>
+              <a:t>=2</a:t>
+            </a:r>
+          </a:p>
+          <a:p>
+            <a:pPr lvl="2"/>
+            <a:r>
+              <a:rPr lang="en-US" dirty="0"/>
+              <a:t>j=1 → 3</a:t>
+            </a:r>
+          </a:p>
+          <a:p>
+            <a:pPr lvl="2"/>
+            <a:r>
+              <a:rPr lang="en-US" dirty="0"/>
+              <a:t>j=2 → 4(even) → +2 → sum=3</a:t>
+            </a:r>
+          </a:p>
+          <a:p>
+            <a:pPr lvl="1"/>
+            <a:r>
+              <a:rPr lang="en-US" dirty="0" err="1"/>
+              <a:t>i</a:t>
+            </a:r>
+            <a:r>
+              <a:rPr lang="en-US" dirty="0"/>
+              <a:t>=3</a:t>
+            </a:r>
+          </a:p>
+          <a:p>
+            <a:pPr lvl="2"/>
+            <a:r>
+              <a:rPr lang="en-US" dirty="0"/>
+              <a:t>j=1 → 4 (even) → +1 → sum=4</a:t>
+            </a:r>
+          </a:p>
+          <a:p>
+            <a:pPr lvl="2"/>
+            <a:r>
+              <a:rPr lang="en-US" dirty="0"/>
+              <a:t>j=2 → 5 (odd)</a:t>
+            </a:r>
+          </a:p>
+          <a:p>
+            <a:pPr lvl="2"/>
+            <a:r>
+              <a:rPr lang="en-US" dirty="0"/>
+              <a:t>j=3 → 6 (even) → +3 → sum=7</a:t>
+            </a:r>
+          </a:p>
+          <a:p>
+            <a:pPr lvl="1"/>
+            <a:r>
+              <a:rPr lang="en-US" dirty="0" err="1"/>
+              <a:t>i</a:t>
+            </a:r>
+            <a:r>
+              <a:rPr lang="en-US" dirty="0"/>
+              <a:t>=4</a:t>
+            </a:r>
+          </a:p>
+          <a:p>
+            <a:pPr lvl="2"/>
+            <a:r>
+              <a:rPr lang="en-US" dirty="0"/>
+              <a:t>j=1 → 5 (odd)</a:t>
+            </a:r>
+          </a:p>
+          <a:p>
+            <a:pPr lvl="2"/>
+            <a:r>
+              <a:rPr lang="en-US" dirty="0"/>
+              <a:t>j=2 → 6 (even) → +2 → sum=9</a:t>
+            </a:r>
+          </a:p>
+          <a:p>
+            <a:pPr lvl="2"/>
+            <a:r>
+              <a:rPr lang="en-US" dirty="0"/>
+              <a:t>j=3 → 7 (odd)</a:t>
+            </a:r>
+          </a:p>
+          <a:p>
+            <a:pPr lvl="2"/>
+            <a:r>
+              <a:rPr lang="en-US" dirty="0"/>
+              <a:t>j=4 → 8 (even) → +4 → sum=13</a:t>
+            </a:r>
+          </a:p>
+          <a:p>
+            <a:pPr lvl="2"/>
+            <a:endParaRPr lang="en-US" dirty="0"/>
+          </a:p>
+        </p:txBody>
+      </p:sp>
+      <p:pic>
+        <p:nvPicPr>
+          <p:cNvPr id="8" name="Content Placeholder 6">
+            <a:extLst>
+              <a:ext uri="{FF2B5EF4-FFF2-40B4-BE49-F238E27FC236}">
+                <a16:creationId xmlns:a16="http://schemas.microsoft.com/office/drawing/2014/main" id="{3AD373F5-91BE-5532-CE2F-4C5A2A454264}"/>
+              </a:ext>
+            </a:extLst>
+          </p:cNvPr>
+          <p:cNvPicPr>
+            <a:picLocks noChangeAspect="1"/>
+          </p:cNvPicPr>
+          <p:nvPr/>
+        </p:nvPicPr>
+        <p:blipFill>
+          <a:blip r:embed="rId2"/>
+          <a:stretch>
+            <a:fillRect/>
+          </a:stretch>
+        </p:blipFill>
+        <p:spPr>
+          <a:xfrm>
+            <a:off x="6356661" y="1990233"/>
+            <a:ext cx="4855249" cy="3903762"/>
+          </a:xfrm>
+          <a:prstGeom prst="rect">
+            <a:avLst/>
+          </a:prstGeom>
+        </p:spPr>
+      </p:pic>
+    </p:spTree>
+    <p:extLst>
+      <p:ext uri="{BB962C8B-B14F-4D97-AF65-F5344CB8AC3E}">
+        <p14:creationId xmlns:p14="http://schemas.microsoft.com/office/powerpoint/2010/main" val="4183839088"/>
+      </p:ext>
+    </p:extLst>
+  </p:cSld>
+  <p:clrMapOvr>
+    <a:masterClrMapping/>
+  </p:clrMapOvr>
+</p:sld>
+</file>
+
+<file path=ppt/slides/slide95.xml><?xml version="1.0" encoding="utf-8"?>
+<p:sld xmlns:a="http://schemas.openxmlformats.org/drawingml/2006/main" xmlns:r="http://schemas.openxmlformats.org/officeDocument/2006/relationships" xmlns:p="http://schemas.openxmlformats.org/presentationml/2006/main">
+  <p:cSld>
+    <p:spTree>
+      <p:nvGrpSpPr>
+        <p:cNvPr id="1" name=""/>
+        <p:cNvGrpSpPr/>
+        <p:nvPr/>
+      </p:nvGrpSpPr>
+      <p:grpSpPr>
+        <a:xfrm>
+          <a:off x="0" y="0"/>
+          <a:ext cx="0" cy="0"/>
+          <a:chOff x="0" y="0"/>
+          <a:chExt cx="0" cy="0"/>
+        </a:xfrm>
+      </p:grpSpPr>
+      <p:sp>
+        <p:nvSpPr>
+          <p:cNvPr id="2" name="Title 1">
+            <a:extLst>
+              <a:ext uri="{FF2B5EF4-FFF2-40B4-BE49-F238E27FC236}">
+                <a16:creationId xmlns:a16="http://schemas.microsoft.com/office/drawing/2014/main" id="{BF064A83-F873-72A7-C405-8ABD45D0BDE1}"/>
+              </a:ext>
+            </a:extLst>
+          </p:cNvPr>
+          <p:cNvSpPr>
+            <a:spLocks noGrp="1"/>
+          </p:cNvSpPr>
+          <p:nvPr>
+            <p:ph type="title"/>
+          </p:nvPr>
+        </p:nvSpPr>
+        <p:spPr/>
+        <p:txBody>
+          <a:bodyPr/>
+          <a:lstStyle/>
+          <a:p>
+            <a:r>
+              <a:rPr lang="en-US" dirty="0"/>
+              <a:t>What does this program do ? Q4</a:t>
+            </a:r>
+          </a:p>
+        </p:txBody>
+      </p:sp>
+      <p:pic>
+        <p:nvPicPr>
+          <p:cNvPr id="5" name="Content Placeholder 4">
+            <a:extLst>
+              <a:ext uri="{FF2B5EF4-FFF2-40B4-BE49-F238E27FC236}">
+                <a16:creationId xmlns:a16="http://schemas.microsoft.com/office/drawing/2014/main" id="{2B868C33-D8B7-9D19-DBFD-BAAA6B1E4A46}"/>
+              </a:ext>
+            </a:extLst>
+          </p:cNvPr>
+          <p:cNvPicPr>
+            <a:picLocks noGrp="1" noChangeAspect="1"/>
+          </p:cNvPicPr>
+          <p:nvPr>
+            <p:ph idx="1"/>
+          </p:nvPr>
+        </p:nvPicPr>
+        <p:blipFill>
+          <a:blip r:embed="rId2"/>
+          <a:stretch>
+            <a:fillRect/>
+          </a:stretch>
+        </p:blipFill>
+        <p:spPr>
+          <a:xfrm>
+            <a:off x="912788" y="1799728"/>
+            <a:ext cx="4100645" cy="4563898"/>
+          </a:xfrm>
+        </p:spPr>
+      </p:pic>
+    </p:spTree>
+    <p:extLst>
+      <p:ext uri="{BB962C8B-B14F-4D97-AF65-F5344CB8AC3E}">
+        <p14:creationId xmlns:p14="http://schemas.microsoft.com/office/powerpoint/2010/main" val="3622320170"/>
+      </p:ext>
+    </p:extLst>
+  </p:cSld>
+  <p:clrMapOvr>
+    <a:masterClrMapping/>
+  </p:clrMapOvr>
+</p:sld>
+</file>
+
+<file path=ppt/slides/slide96.xml><?xml version="1.0" encoding="utf-8"?>
+<p:sld xmlns:a="http://schemas.openxmlformats.org/drawingml/2006/main" xmlns:r="http://schemas.openxmlformats.org/officeDocument/2006/relationships" xmlns:p="http://schemas.openxmlformats.org/presentationml/2006/main">
+  <p:cSld>
+    <p:spTree>
+      <p:nvGrpSpPr>
+        <p:cNvPr id="1" name="">
+          <a:extLst>
+            <a:ext uri="{FF2B5EF4-FFF2-40B4-BE49-F238E27FC236}">
+              <a16:creationId xmlns:a16="http://schemas.microsoft.com/office/drawing/2014/main" id="{E2E81A11-13A6-13EA-2BBF-E3F325435E64}"/>
+            </a:ext>
+          </a:extLst>
+        </p:cNvPr>
+        <p:cNvGrpSpPr/>
+        <p:nvPr/>
+      </p:nvGrpSpPr>
+      <p:grpSpPr>
+        <a:xfrm>
+          <a:off x="0" y="0"/>
+          <a:ext cx="0" cy="0"/>
+          <a:chOff x="0" y="0"/>
+          <a:chExt cx="0" cy="0"/>
+        </a:xfrm>
+      </p:grpSpPr>
+      <p:sp>
+        <p:nvSpPr>
+          <p:cNvPr id="2" name="Title 1">
+            <a:extLst>
+              <a:ext uri="{FF2B5EF4-FFF2-40B4-BE49-F238E27FC236}">
+                <a16:creationId xmlns:a16="http://schemas.microsoft.com/office/drawing/2014/main" id="{43C073A9-D3A1-EA46-9965-88D807526F59}"/>
+              </a:ext>
+            </a:extLst>
+          </p:cNvPr>
+          <p:cNvSpPr>
+            <a:spLocks noGrp="1"/>
+          </p:cNvSpPr>
+          <p:nvPr>
+            <p:ph type="title"/>
+          </p:nvPr>
+        </p:nvSpPr>
+        <p:spPr/>
+        <p:txBody>
+          <a:bodyPr/>
+          <a:lstStyle/>
+          <a:p>
+            <a:r>
+              <a:rPr lang="en-US" dirty="0"/>
+              <a:t>What does this program do ? A4</a:t>
+            </a:r>
+          </a:p>
+        </p:txBody>
+      </p:sp>
+      <p:sp>
+        <p:nvSpPr>
+          <p:cNvPr id="4" name="Content Placeholder 3">
+            <a:extLst>
+              <a:ext uri="{FF2B5EF4-FFF2-40B4-BE49-F238E27FC236}">
+                <a16:creationId xmlns:a16="http://schemas.microsoft.com/office/drawing/2014/main" id="{FAF4CA66-2E1D-A65D-96B1-7D63B9B6342F}"/>
+              </a:ext>
+            </a:extLst>
+          </p:cNvPr>
+          <p:cNvSpPr>
+            <a:spLocks noGrp="1"/>
+          </p:cNvSpPr>
+          <p:nvPr>
+            <p:ph idx="1"/>
+          </p:nvPr>
+        </p:nvSpPr>
+        <p:spPr/>
+        <p:txBody>
+          <a:bodyPr/>
+          <a:lstStyle/>
+          <a:p>
+            <a:r>
+              <a:rPr lang="en-US" dirty="0"/>
+              <a:t>6</a:t>
+            </a:r>
+          </a:p>
+          <a:p>
+            <a:r>
+              <a:rPr lang="en-US" dirty="0"/>
+              <a:t>Count how many times A[</a:t>
+            </a:r>
+            <a:r>
+              <a:rPr lang="en-US" dirty="0" err="1"/>
+              <a:t>i</a:t>
+            </a:r>
+            <a:r>
+              <a:rPr lang="en-US" dirty="0"/>
+              <a:t>] &lt; A[j]</a:t>
+            </a:r>
+          </a:p>
+          <a:p>
+            <a:pPr lvl="1"/>
+            <a:r>
+              <a:rPr lang="it-IT" dirty="0"/>
+              <a:t>1 &lt; 3,5,7 → 3</a:t>
+            </a:r>
+          </a:p>
+          <a:p>
+            <a:pPr lvl="1"/>
+            <a:r>
+              <a:rPr lang="it-IT" dirty="0"/>
+              <a:t>3 &lt; 5,7 → 2</a:t>
+            </a:r>
+          </a:p>
+          <a:p>
+            <a:pPr lvl="1"/>
+            <a:r>
+              <a:rPr lang="it-IT" dirty="0"/>
+              <a:t>5 &lt; 7 → 1</a:t>
+            </a:r>
+          </a:p>
+          <a:p>
+            <a:pPr lvl="1"/>
+            <a:r>
+              <a:rPr lang="it-IT" dirty="0"/>
+              <a:t>7 &lt; none → 0</a:t>
+            </a:r>
+            <a:endParaRPr lang="en-US" dirty="0"/>
+          </a:p>
+          <a:p>
+            <a:r>
+              <a:rPr lang="en-US" dirty="0"/>
+              <a:t>Total = 3 + 2 + 1 = 6</a:t>
+            </a:r>
+            <a:endParaRPr lang="it-IT" dirty="0"/>
+          </a:p>
+        </p:txBody>
+      </p:sp>
+      <p:pic>
+        <p:nvPicPr>
+          <p:cNvPr id="6" name="Content Placeholder 4">
+            <a:extLst>
+              <a:ext uri="{FF2B5EF4-FFF2-40B4-BE49-F238E27FC236}">
+                <a16:creationId xmlns:a16="http://schemas.microsoft.com/office/drawing/2014/main" id="{665AAB9F-0F4E-0B93-A910-68451237E38F}"/>
+              </a:ext>
+            </a:extLst>
+          </p:cNvPr>
+          <p:cNvPicPr>
+            <a:picLocks noChangeAspect="1"/>
+          </p:cNvPicPr>
+          <p:nvPr/>
+        </p:nvPicPr>
+        <p:blipFill>
+          <a:blip r:embed="rId2"/>
+          <a:stretch>
+            <a:fillRect/>
+          </a:stretch>
+        </p:blipFill>
+        <p:spPr>
+          <a:xfrm>
+            <a:off x="6794937" y="1690687"/>
+            <a:ext cx="3909659" cy="4351337"/>
+          </a:xfrm>
+          <a:prstGeom prst="rect">
+            <a:avLst/>
+          </a:prstGeom>
+        </p:spPr>
+      </p:pic>
+    </p:spTree>
+    <p:extLst>
+      <p:ext uri="{BB962C8B-B14F-4D97-AF65-F5344CB8AC3E}">
+        <p14:creationId xmlns:p14="http://schemas.microsoft.com/office/powerpoint/2010/main" val="3862395078"/>
+      </p:ext>
+    </p:extLst>
+  </p:cSld>
+  <p:clrMapOvr>
+    <a:masterClrMapping/>
+  </p:clrMapOvr>
+</p:sld>
+</file>
+
+<file path=ppt/slides/slide97.xml><?xml version="1.0" encoding="utf-8"?>
+<p:sld xmlns:a="http://schemas.openxmlformats.org/drawingml/2006/main" xmlns:r="http://schemas.openxmlformats.org/officeDocument/2006/relationships" xmlns:p="http://schemas.openxmlformats.org/presentationml/2006/main">
+  <p:cSld>
+    <p:spTree>
+      <p:nvGrpSpPr>
+        <p:cNvPr id="1" name="">
+          <a:extLst>
+            <a:ext uri="{FF2B5EF4-FFF2-40B4-BE49-F238E27FC236}">
+              <a16:creationId xmlns:a16="http://schemas.microsoft.com/office/drawing/2014/main" id="{1ED58E75-5553-324F-5B48-028B76BBD095}"/>
+            </a:ext>
+          </a:extLst>
+        </p:cNvPr>
+        <p:cNvGrpSpPr/>
+        <p:nvPr/>
+      </p:nvGrpSpPr>
+      <p:grpSpPr>
+        <a:xfrm>
+          <a:off x="0" y="0"/>
+          <a:ext cx="0" cy="0"/>
+          <a:chOff x="0" y="0"/>
+          <a:chExt cx="0" cy="0"/>
+        </a:xfrm>
+      </p:grpSpPr>
+      <p:sp>
+        <p:nvSpPr>
+          <p:cNvPr id="2" name="Title 1">
+            <a:extLst>
+              <a:ext uri="{FF2B5EF4-FFF2-40B4-BE49-F238E27FC236}">
+                <a16:creationId xmlns:a16="http://schemas.microsoft.com/office/drawing/2014/main" id="{52D274CD-93BF-0487-A229-2394EC9B262E}"/>
+              </a:ext>
+            </a:extLst>
+          </p:cNvPr>
+          <p:cNvSpPr>
+            <a:spLocks noGrp="1"/>
+          </p:cNvSpPr>
+          <p:nvPr>
+            <p:ph type="title"/>
+          </p:nvPr>
+        </p:nvSpPr>
+        <p:spPr/>
+        <p:txBody>
+          <a:bodyPr/>
+          <a:lstStyle/>
+          <a:p>
+            <a:r>
+              <a:rPr lang="en-US" dirty="0"/>
+              <a:t>What does this program do ? Q5</a:t>
+            </a:r>
+          </a:p>
+        </p:txBody>
+      </p:sp>
+      <p:pic>
+        <p:nvPicPr>
+          <p:cNvPr id="10" name="Content Placeholder 4">
+            <a:extLst>
+              <a:ext uri="{FF2B5EF4-FFF2-40B4-BE49-F238E27FC236}">
+                <a16:creationId xmlns:a16="http://schemas.microsoft.com/office/drawing/2014/main" id="{43C46BAF-D801-5E6F-3276-708F9CF1C94E}"/>
+              </a:ext>
+            </a:extLst>
+          </p:cNvPr>
+          <p:cNvPicPr>
+            <a:picLocks noGrp="1" noChangeAspect="1"/>
+          </p:cNvPicPr>
+          <p:nvPr>
+            <p:ph idx="1"/>
+          </p:nvPr>
+        </p:nvPicPr>
+        <p:blipFill>
+          <a:blip r:embed="rId2"/>
+          <a:stretch>
+            <a:fillRect/>
+          </a:stretch>
+        </p:blipFill>
+        <p:spPr>
+          <a:xfrm>
+            <a:off x="1531615" y="1616107"/>
+            <a:ext cx="2220578" cy="4746673"/>
+          </a:xfrm>
+          <a:prstGeom prst="rect">
+            <a:avLst/>
+          </a:prstGeom>
+        </p:spPr>
+      </p:pic>
+    </p:spTree>
+    <p:extLst>
+      <p:ext uri="{BB962C8B-B14F-4D97-AF65-F5344CB8AC3E}">
+        <p14:creationId xmlns:p14="http://schemas.microsoft.com/office/powerpoint/2010/main" val="2481855417"/>
+      </p:ext>
+    </p:extLst>
+  </p:cSld>
+  <p:clrMapOvr>
+    <a:masterClrMapping/>
+  </p:clrMapOvr>
+</p:sld>
+</file>
+
+<file path=ppt/slides/slide98.xml><?xml version="1.0" encoding="utf-8"?>
+<p:sld xmlns:a="http://schemas.openxmlformats.org/drawingml/2006/main" xmlns:r="http://schemas.openxmlformats.org/officeDocument/2006/relationships" xmlns:p="http://schemas.openxmlformats.org/presentationml/2006/main">
+  <p:cSld>
+    <p:spTree>
+      <p:nvGrpSpPr>
+        <p:cNvPr id="1" name="">
+          <a:extLst>
+            <a:ext uri="{FF2B5EF4-FFF2-40B4-BE49-F238E27FC236}">
+              <a16:creationId xmlns:a16="http://schemas.microsoft.com/office/drawing/2014/main" id="{46A29693-7FD9-47E4-BA86-B97EB9408F3A}"/>
+            </a:ext>
+          </a:extLst>
+        </p:cNvPr>
+        <p:cNvGrpSpPr/>
+        <p:nvPr/>
+      </p:nvGrpSpPr>
+      <p:grpSpPr>
+        <a:xfrm>
+          <a:off x="0" y="0"/>
+          <a:ext cx="0" cy="0"/>
+          <a:chOff x="0" y="0"/>
+          <a:chExt cx="0" cy="0"/>
+        </a:xfrm>
+      </p:grpSpPr>
+      <p:sp>
+        <p:nvSpPr>
+          <p:cNvPr id="2" name="Title 1">
+            <a:extLst>
+              <a:ext uri="{FF2B5EF4-FFF2-40B4-BE49-F238E27FC236}">
+                <a16:creationId xmlns:a16="http://schemas.microsoft.com/office/drawing/2014/main" id="{1B8C0844-6D66-B048-A14A-CE67FE9B5BAB}"/>
+              </a:ext>
+            </a:extLst>
+          </p:cNvPr>
+          <p:cNvSpPr>
+            <a:spLocks noGrp="1"/>
+          </p:cNvSpPr>
+          <p:nvPr>
+            <p:ph type="title"/>
+          </p:nvPr>
+        </p:nvSpPr>
+        <p:spPr/>
+        <p:txBody>
+          <a:bodyPr/>
+          <a:lstStyle/>
+          <a:p>
+            <a:r>
+              <a:rPr lang="en-US" dirty="0"/>
+              <a:t>What does this program do ? Q5</a:t>
+            </a:r>
+          </a:p>
+        </p:txBody>
+      </p:sp>
+      <p:sp>
+        <p:nvSpPr>
+          <p:cNvPr id="4" name="Content Placeholder 3">
+            <a:extLst>
+              <a:ext uri="{FF2B5EF4-FFF2-40B4-BE49-F238E27FC236}">
+                <a16:creationId xmlns:a16="http://schemas.microsoft.com/office/drawing/2014/main" id="{B0DFC1A9-4F46-A34B-EC6F-15BA81F9E6DE}"/>
+              </a:ext>
+            </a:extLst>
+          </p:cNvPr>
+          <p:cNvSpPr>
+            <a:spLocks noGrp="1"/>
+          </p:cNvSpPr>
+          <p:nvPr>
+            <p:ph idx="1"/>
+          </p:nvPr>
+        </p:nvSpPr>
+        <p:spPr/>
+        <p:txBody>
+          <a:bodyPr/>
+          <a:lstStyle/>
+          <a:p>
+            <a:r>
+              <a:rPr lang="en-US" dirty="0"/>
+              <a:t>5 2 1</a:t>
+            </a:r>
+          </a:p>
+          <a:p>
+            <a:pPr lvl="1"/>
+            <a:r>
+              <a:rPr lang="en-US" dirty="0"/>
+              <a:t>Push 1,2,3,4</a:t>
+            </a:r>
+          </a:p>
+          <a:p>
+            <a:pPr lvl="1"/>
+            <a:r>
+              <a:rPr lang="en-US" dirty="0"/>
+              <a:t>Pop twice </a:t>
+            </a:r>
+          </a:p>
+          <a:p>
+            <a:pPr lvl="2"/>
+            <a:r>
+              <a:rPr lang="en-US" dirty="0"/>
+              <a:t>4 </a:t>
+            </a:r>
+            <a:r>
+              <a:rPr lang="en-US" dirty="0">
+                <a:sym typeface="Wingdings" panose="05000000000000000000" pitchFamily="2" charset="2"/>
+              </a:rPr>
+              <a:t></a:t>
+            </a:r>
+            <a:r>
+              <a:rPr lang="en-US" dirty="0"/>
+              <a:t> 1,2,3</a:t>
+            </a:r>
+          </a:p>
+          <a:p>
+            <a:pPr lvl="2"/>
+            <a:r>
+              <a:rPr lang="en-US" dirty="0"/>
+              <a:t>3 </a:t>
+            </a:r>
+            <a:r>
+              <a:rPr lang="en-US" dirty="0">
+                <a:sym typeface="Wingdings" panose="05000000000000000000" pitchFamily="2" charset="2"/>
+              </a:rPr>
+              <a:t> 1,2</a:t>
+            </a:r>
+          </a:p>
+          <a:p>
+            <a:pPr lvl="1"/>
+            <a:r>
+              <a:rPr lang="en-US" dirty="0">
+                <a:sym typeface="Wingdings" panose="05000000000000000000" pitchFamily="2" charset="2"/>
+              </a:rPr>
+              <a:t>Push 5</a:t>
+            </a:r>
+          </a:p>
+          <a:p>
+            <a:pPr lvl="2"/>
+            <a:r>
+              <a:rPr lang="en-US" dirty="0">
+                <a:sym typeface="Wingdings" panose="05000000000000000000" pitchFamily="2" charset="2"/>
+              </a:rPr>
+              <a:t>1,2,5</a:t>
+            </a:r>
+          </a:p>
+          <a:p>
+            <a:pPr lvl="1"/>
+            <a:r>
+              <a:rPr lang="en-US" dirty="0">
+                <a:sym typeface="Wingdings" panose="05000000000000000000" pitchFamily="2" charset="2"/>
+              </a:rPr>
+              <a:t>Pop all </a:t>
+            </a:r>
+          </a:p>
+          <a:p>
+            <a:pPr lvl="2"/>
+            <a:r>
+              <a:rPr lang="en-US" dirty="0">
+                <a:sym typeface="Wingdings" panose="05000000000000000000" pitchFamily="2" charset="2"/>
+              </a:rPr>
+              <a:t>5,2,1</a:t>
+            </a:r>
+            <a:endParaRPr lang="en-US" dirty="0"/>
+          </a:p>
+        </p:txBody>
+      </p:sp>
+      <p:pic>
+        <p:nvPicPr>
+          <p:cNvPr id="6" name="Content Placeholder 4">
+            <a:extLst>
+              <a:ext uri="{FF2B5EF4-FFF2-40B4-BE49-F238E27FC236}">
+                <a16:creationId xmlns:a16="http://schemas.microsoft.com/office/drawing/2014/main" id="{04979409-7BA8-5D3F-228C-B55060B2B27A}"/>
+              </a:ext>
+            </a:extLst>
+          </p:cNvPr>
+          <p:cNvPicPr>
+            <a:picLocks noChangeAspect="1"/>
+          </p:cNvPicPr>
+          <p:nvPr/>
+        </p:nvPicPr>
+        <p:blipFill>
+          <a:blip r:embed="rId2"/>
+          <a:stretch>
+            <a:fillRect/>
+          </a:stretch>
+        </p:blipFill>
+        <p:spPr>
+          <a:xfrm>
+            <a:off x="5622767" y="1690688"/>
+            <a:ext cx="2039275" cy="4359122"/>
+          </a:xfrm>
+          <a:prstGeom prst="rect">
+            <a:avLst/>
+          </a:prstGeom>
+        </p:spPr>
+      </p:pic>
+    </p:spTree>
+    <p:extLst>
+      <p:ext uri="{BB962C8B-B14F-4D97-AF65-F5344CB8AC3E}">
+        <p14:creationId xmlns:p14="http://schemas.microsoft.com/office/powerpoint/2010/main" val="3411203417"/>
+      </p:ext>
+    </p:extLst>
+  </p:cSld>
+  <p:clrMapOvr>
+    <a:masterClrMapping/>
+  </p:clrMapOvr>
+</p:sld>
+</file>
+
+<file path=ppt/slides/slide99.xml><?xml version="1.0" encoding="utf-8"?>
+<p:sld xmlns:a="http://schemas.openxmlformats.org/drawingml/2006/main" xmlns:r="http://schemas.openxmlformats.org/officeDocument/2006/relationships" xmlns:p="http://schemas.openxmlformats.org/presentationml/2006/main">
+  <p:cSld>
+    <p:spTree>
+      <p:nvGrpSpPr>
+        <p:cNvPr id="1" name="">
+          <a:extLst>
+            <a:ext uri="{FF2B5EF4-FFF2-40B4-BE49-F238E27FC236}">
+              <a16:creationId xmlns:a16="http://schemas.microsoft.com/office/drawing/2014/main" id="{1795AF1E-B94B-B679-DF50-9B417918A5DA}"/>
+            </a:ext>
+          </a:extLst>
+        </p:cNvPr>
+        <p:cNvGrpSpPr/>
+        <p:nvPr/>
+      </p:nvGrpSpPr>
+      <p:grpSpPr>
+        <a:xfrm>
+          <a:off x="0" y="0"/>
+          <a:ext cx="0" cy="0"/>
+          <a:chOff x="0" y="0"/>
+          <a:chExt cx="0" cy="0"/>
+        </a:xfrm>
+      </p:grpSpPr>
+      <p:sp>
+        <p:nvSpPr>
+          <p:cNvPr id="2" name="Title 1">
+            <a:extLst>
+              <a:ext uri="{FF2B5EF4-FFF2-40B4-BE49-F238E27FC236}">
+                <a16:creationId xmlns:a16="http://schemas.microsoft.com/office/drawing/2014/main" id="{F6280D29-E26E-CC89-ED61-E18E39F86FC7}"/>
+              </a:ext>
+            </a:extLst>
+          </p:cNvPr>
+          <p:cNvSpPr>
+            <a:spLocks noGrp="1"/>
+          </p:cNvSpPr>
+          <p:nvPr>
+            <p:ph type="title"/>
+          </p:nvPr>
+        </p:nvSpPr>
+        <p:spPr/>
+        <p:txBody>
+          <a:bodyPr/>
+          <a:lstStyle/>
+          <a:p>
+            <a:r>
+              <a:rPr lang="en-US" dirty="0"/>
+              <a:t>What does this program do ? Q6</a:t>
+            </a:r>
+          </a:p>
+        </p:txBody>
+      </p:sp>
+      <p:pic>
+        <p:nvPicPr>
+          <p:cNvPr id="5" name="Content Placeholder 4">
+            <a:extLst>
+              <a:ext uri="{FF2B5EF4-FFF2-40B4-BE49-F238E27FC236}">
+                <a16:creationId xmlns:a16="http://schemas.microsoft.com/office/drawing/2014/main" id="{E720711A-4624-D6E5-76BF-5063A92FAF86}"/>
+              </a:ext>
+            </a:extLst>
+          </p:cNvPr>
+          <p:cNvPicPr>
+            <a:picLocks noGrp="1" noChangeAspect="1"/>
+          </p:cNvPicPr>
+          <p:nvPr>
+            <p:ph idx="1"/>
+          </p:nvPr>
+        </p:nvPicPr>
+        <p:blipFill>
+          <a:blip r:embed="rId2"/>
+          <a:stretch>
+            <a:fillRect/>
+          </a:stretch>
+        </p:blipFill>
+        <p:spPr>
+          <a:xfrm>
+            <a:off x="925588" y="1690688"/>
+            <a:ext cx="5122423" cy="4260795"/>
+          </a:xfrm>
+        </p:spPr>
+      </p:pic>
+    </p:spTree>
+    <p:extLst>
+      <p:ext uri="{BB962C8B-B14F-4D97-AF65-F5344CB8AC3E}">
+        <p14:creationId xmlns:p14="http://schemas.microsoft.com/office/powerpoint/2010/main" val="386232854"/>
       </p:ext>
     </p:extLst>
   </p:cSld>

</xml_diff>